<commit_message>
finish role playing evaluaiton code
</commit_message>
<xml_diff>
--- a/Presentation/De-escalation Training Evaluation Idea.pptx
+++ b/Presentation/De-escalation Training Evaluation Idea.pptx
@@ -5,16 +5,17 @@
     <p:sldMasterId id="2147483659" r:id="rId1"/>
   </p:sldMasterIdLst>
   <p:notesMasterIdLst>
-    <p:notesMasterId r:id="rId9"/>
+    <p:notesMasterId r:id="rId10"/>
   </p:notesMasterIdLst>
   <p:sldIdLst>
     <p:sldId id="256" r:id="rId2"/>
     <p:sldId id="257" r:id="rId3"/>
-    <p:sldId id="258" r:id="rId4"/>
-    <p:sldId id="259" r:id="rId5"/>
-    <p:sldId id="260" r:id="rId6"/>
-    <p:sldId id="261" r:id="rId7"/>
-    <p:sldId id="262" r:id="rId8"/>
+    <p:sldId id="263" r:id="rId4"/>
+    <p:sldId id="264" r:id="rId5"/>
+    <p:sldId id="258" r:id="rId6"/>
+    <p:sldId id="259" r:id="rId7"/>
+    <p:sldId id="260" r:id="rId8"/>
+    <p:sldId id="261" r:id="rId9"/>
   </p:sldIdLst>
   <p:sldSz cx="9144000" cy="5143500" type="screen16x9"/>
   <p:notesSz cx="6858000" cy="9144000"/>
@@ -736,8 +737,8 @@
         </p:nvSpPr>
         <p:spPr>
           <a:xfrm>
-            <a:off x="381300" y="685800"/>
-            <a:ext cx="6096075" cy="3429000"/>
+            <a:off x="381000" y="685800"/>
+            <a:ext cx="6096000" cy="3429000"/>
           </a:xfrm>
           <a:custGeom>
             <a:avLst/>
@@ -840,7 +841,7 @@
         </p:nvSpPr>
         <p:spPr>
           <a:xfrm>
-            <a:off x="381300" y="685800"/>
+            <a:off x="381000" y="685800"/>
             <a:ext cx="6096000" cy="3429000"/>
           </a:xfrm>
           <a:custGeom>
@@ -920,6 +921,260 @@
   <p:cSld>
     <p:spTree>
       <p:nvGrpSpPr>
+        <p:cNvPr id="1" name="Shape 56">
+          <a:extLst>
+            <a:ext uri="{FF2B5EF4-FFF2-40B4-BE49-F238E27FC236}">
+              <a16:creationId xmlns:a16="http://schemas.microsoft.com/office/drawing/2014/main" id="{4B12CF1A-32C7-904E-92A0-F50176AB4830}"/>
+            </a:ext>
+          </a:extLst>
+        </p:cNvPr>
+        <p:cNvGrpSpPr/>
+        <p:nvPr/>
+      </p:nvGrpSpPr>
+      <p:grpSpPr>
+        <a:xfrm>
+          <a:off x="0" y="0"/>
+          <a:ext cx="0" cy="0"/>
+          <a:chOff x="0" y="0"/>
+          <a:chExt cx="0" cy="0"/>
+        </a:xfrm>
+      </p:grpSpPr>
+      <p:sp>
+        <p:nvSpPr>
+          <p:cNvPr id="57" name="Google Shape;57;g37bb7e5019d_0_0:notes">
+            <a:extLst>
+              <a:ext uri="{FF2B5EF4-FFF2-40B4-BE49-F238E27FC236}">
+                <a16:creationId xmlns:a16="http://schemas.microsoft.com/office/drawing/2014/main" id="{EB7B162B-75EC-4F6F-7490-29EA6FAFECB4}"/>
+              </a:ext>
+            </a:extLst>
+          </p:cNvPr>
+          <p:cNvSpPr>
+            <a:spLocks noGrp="1" noRot="1" noChangeAspect="1"/>
+          </p:cNvSpPr>
+          <p:nvPr>
+            <p:ph type="sldImg" idx="2"/>
+          </p:nvPr>
+        </p:nvSpPr>
+        <p:spPr>
+          <a:xfrm>
+            <a:off x="381000" y="685800"/>
+            <a:ext cx="6096000" cy="3429000"/>
+          </a:xfrm>
+          <a:custGeom>
+            <a:avLst/>
+            <a:gdLst/>
+            <a:ahLst/>
+            <a:cxnLst/>
+            <a:rect l="l" t="t" r="r" b="b"/>
+            <a:pathLst>
+              <a:path w="120000" h="120000" extrusionOk="0">
+                <a:moveTo>
+                  <a:pt x="0" y="0"/>
+                </a:moveTo>
+                <a:lnTo>
+                  <a:pt x="120000" y="0"/>
+                </a:lnTo>
+                <a:lnTo>
+                  <a:pt x="120000" y="120000"/>
+                </a:lnTo>
+                <a:lnTo>
+                  <a:pt x="0" y="120000"/>
+                </a:lnTo>
+                <a:close/>
+              </a:path>
+            </a:pathLst>
+          </a:custGeom>
+        </p:spPr>
+      </p:sp>
+      <p:sp>
+        <p:nvSpPr>
+          <p:cNvPr id="58" name="Google Shape;58;g37bb7e5019d_0_0:notes">
+            <a:extLst>
+              <a:ext uri="{FF2B5EF4-FFF2-40B4-BE49-F238E27FC236}">
+                <a16:creationId xmlns:a16="http://schemas.microsoft.com/office/drawing/2014/main" id="{76CC0476-1695-A931-352D-F76531B9F2A9}"/>
+              </a:ext>
+            </a:extLst>
+          </p:cNvPr>
+          <p:cNvSpPr txBox="1">
+            <a:spLocks noGrp="1"/>
+          </p:cNvSpPr>
+          <p:nvPr>
+            <p:ph type="body" idx="1"/>
+          </p:nvPr>
+        </p:nvSpPr>
+        <p:spPr>
+          <a:xfrm>
+            <a:off x="685800" y="4343400"/>
+            <a:ext cx="5486400" cy="4114800"/>
+          </a:xfrm>
+          <a:prstGeom prst="rect">
+            <a:avLst/>
+          </a:prstGeom>
+        </p:spPr>
+        <p:txBody>
+          <a:bodyPr spcFirstLastPara="1" wrap="square" lIns="91425" tIns="91425" rIns="91425" bIns="91425" anchor="t" anchorCtr="0">
+            <a:noAutofit/>
+          </a:bodyPr>
+          <a:lstStyle/>
+          <a:p>
+            <a:pPr marL="0" lvl="0" indent="0" algn="l" rtl="0">
+              <a:spcBef>
+                <a:spcPts val="0"/>
+              </a:spcBef>
+              <a:spcAft>
+                <a:spcPts val="0"/>
+              </a:spcAft>
+              <a:buNone/>
+            </a:pPr>
+            <a:endParaRPr/>
+          </a:p>
+        </p:txBody>
+      </p:sp>
+    </p:spTree>
+    <p:extLst>
+      <p:ext uri="{BB962C8B-B14F-4D97-AF65-F5344CB8AC3E}">
+        <p14:creationId xmlns:p14="http://schemas.microsoft.com/office/powerpoint/2010/main" val="3206835957"/>
+      </p:ext>
+    </p:extLst>
+  </p:cSld>
+  <p:clrMapOvr>
+    <a:masterClrMapping/>
+  </p:clrMapOvr>
+</p:notes>
+</file>
+
+<file path=ppt/notesSlides/notesSlide4.xml><?xml version="1.0" encoding="utf-8"?>
+<p:notes xmlns:a="http://schemas.openxmlformats.org/drawingml/2006/main" xmlns:r="http://schemas.openxmlformats.org/officeDocument/2006/relationships" xmlns:p="http://schemas.openxmlformats.org/presentationml/2006/main" showMasterSp="0" showMasterPhAnim="0">
+  <p:cSld>
+    <p:spTree>
+      <p:nvGrpSpPr>
+        <p:cNvPr id="1" name="Shape 56">
+          <a:extLst>
+            <a:ext uri="{FF2B5EF4-FFF2-40B4-BE49-F238E27FC236}">
+              <a16:creationId xmlns:a16="http://schemas.microsoft.com/office/drawing/2014/main" id="{4B674584-D1F9-BA85-7A6C-C7A37D576E98}"/>
+            </a:ext>
+          </a:extLst>
+        </p:cNvPr>
+        <p:cNvGrpSpPr/>
+        <p:nvPr/>
+      </p:nvGrpSpPr>
+      <p:grpSpPr>
+        <a:xfrm>
+          <a:off x="0" y="0"/>
+          <a:ext cx="0" cy="0"/>
+          <a:chOff x="0" y="0"/>
+          <a:chExt cx="0" cy="0"/>
+        </a:xfrm>
+      </p:grpSpPr>
+      <p:sp>
+        <p:nvSpPr>
+          <p:cNvPr id="57" name="Google Shape;57;g37bb7e5019d_0_0:notes">
+            <a:extLst>
+              <a:ext uri="{FF2B5EF4-FFF2-40B4-BE49-F238E27FC236}">
+                <a16:creationId xmlns:a16="http://schemas.microsoft.com/office/drawing/2014/main" id="{DD489891-96BD-80FE-C33A-88F8CD874D17}"/>
+              </a:ext>
+            </a:extLst>
+          </p:cNvPr>
+          <p:cNvSpPr>
+            <a:spLocks noGrp="1" noRot="1" noChangeAspect="1"/>
+          </p:cNvSpPr>
+          <p:nvPr>
+            <p:ph type="sldImg" idx="2"/>
+          </p:nvPr>
+        </p:nvSpPr>
+        <p:spPr>
+          <a:xfrm>
+            <a:off x="381000" y="685800"/>
+            <a:ext cx="6096000" cy="3429000"/>
+          </a:xfrm>
+          <a:custGeom>
+            <a:avLst/>
+            <a:gdLst/>
+            <a:ahLst/>
+            <a:cxnLst/>
+            <a:rect l="l" t="t" r="r" b="b"/>
+            <a:pathLst>
+              <a:path w="120000" h="120000" extrusionOk="0">
+                <a:moveTo>
+                  <a:pt x="0" y="0"/>
+                </a:moveTo>
+                <a:lnTo>
+                  <a:pt x="120000" y="0"/>
+                </a:lnTo>
+                <a:lnTo>
+                  <a:pt x="120000" y="120000"/>
+                </a:lnTo>
+                <a:lnTo>
+                  <a:pt x="0" y="120000"/>
+                </a:lnTo>
+                <a:close/>
+              </a:path>
+            </a:pathLst>
+          </a:custGeom>
+        </p:spPr>
+      </p:sp>
+      <p:sp>
+        <p:nvSpPr>
+          <p:cNvPr id="58" name="Google Shape;58;g37bb7e5019d_0_0:notes">
+            <a:extLst>
+              <a:ext uri="{FF2B5EF4-FFF2-40B4-BE49-F238E27FC236}">
+                <a16:creationId xmlns:a16="http://schemas.microsoft.com/office/drawing/2014/main" id="{7708253F-7FA2-B4B9-DE87-5A0FBB9BB813}"/>
+              </a:ext>
+            </a:extLst>
+          </p:cNvPr>
+          <p:cNvSpPr txBox="1">
+            <a:spLocks noGrp="1"/>
+          </p:cNvSpPr>
+          <p:nvPr>
+            <p:ph type="body" idx="1"/>
+          </p:nvPr>
+        </p:nvSpPr>
+        <p:spPr>
+          <a:xfrm>
+            <a:off x="685800" y="4343400"/>
+            <a:ext cx="5486400" cy="4114800"/>
+          </a:xfrm>
+          <a:prstGeom prst="rect">
+            <a:avLst/>
+          </a:prstGeom>
+        </p:spPr>
+        <p:txBody>
+          <a:bodyPr spcFirstLastPara="1" wrap="square" lIns="91425" tIns="91425" rIns="91425" bIns="91425" anchor="t" anchorCtr="0">
+            <a:noAutofit/>
+          </a:bodyPr>
+          <a:lstStyle/>
+          <a:p>
+            <a:pPr marL="0" lvl="0" indent="0" algn="l" rtl="0">
+              <a:spcBef>
+                <a:spcPts val="0"/>
+              </a:spcBef>
+              <a:spcAft>
+                <a:spcPts val="0"/>
+              </a:spcAft>
+              <a:buNone/>
+            </a:pPr>
+            <a:endParaRPr/>
+          </a:p>
+        </p:txBody>
+      </p:sp>
+    </p:spTree>
+    <p:extLst>
+      <p:ext uri="{BB962C8B-B14F-4D97-AF65-F5344CB8AC3E}">
+        <p14:creationId xmlns:p14="http://schemas.microsoft.com/office/powerpoint/2010/main" val="562545207"/>
+      </p:ext>
+    </p:extLst>
+  </p:cSld>
+  <p:clrMapOvr>
+    <a:masterClrMapping/>
+  </p:clrMapOvr>
+</p:notes>
+</file>
+
+<file path=ppt/notesSlides/notesSlide5.xml><?xml version="1.0" encoding="utf-8"?>
+<p:notes xmlns:a="http://schemas.openxmlformats.org/drawingml/2006/main" xmlns:r="http://schemas.openxmlformats.org/officeDocument/2006/relationships" xmlns:p="http://schemas.openxmlformats.org/presentationml/2006/main" showMasterSp="0" showMasterPhAnim="0">
+  <p:cSld>
+    <p:spTree>
+      <p:nvGrpSpPr>
         <p:cNvPr id="1" name="Shape 62"/>
         <p:cNvGrpSpPr/>
         <p:nvPr/>
@@ -944,7 +1199,7 @@
         </p:nvSpPr>
         <p:spPr>
           <a:xfrm>
-            <a:off x="381300" y="685800"/>
+            <a:off x="381000" y="685800"/>
             <a:ext cx="6096000" cy="3429000"/>
           </a:xfrm>
           <a:custGeom>
@@ -1019,7 +1274,7 @@
 </p:notes>
 </file>
 
-<file path=ppt/notesSlides/notesSlide4.xml><?xml version="1.0" encoding="utf-8"?>
+<file path=ppt/notesSlides/notesSlide6.xml><?xml version="1.0" encoding="utf-8"?>
 <p:notes xmlns:a="http://schemas.openxmlformats.org/drawingml/2006/main" xmlns:r="http://schemas.openxmlformats.org/officeDocument/2006/relationships" xmlns:p="http://schemas.openxmlformats.org/presentationml/2006/main" showMasterSp="0" showMasterPhAnim="0">
   <p:cSld>
     <p:spTree>
@@ -1123,7 +1378,7 @@
 </p:notes>
 </file>
 
-<file path=ppt/notesSlides/notesSlide5.xml><?xml version="1.0" encoding="utf-8"?>
+<file path=ppt/notesSlides/notesSlide7.xml><?xml version="1.0" encoding="utf-8"?>
 <p:notes xmlns:a="http://schemas.openxmlformats.org/drawingml/2006/main" xmlns:r="http://schemas.openxmlformats.org/officeDocument/2006/relationships" xmlns:p="http://schemas.openxmlformats.org/presentationml/2006/main" showMasterSp="0" showMasterPhAnim="0">
   <p:cSld>
     <p:spTree>
@@ -1227,7 +1482,7 @@
 </p:notes>
 </file>
 
-<file path=ppt/notesSlides/notesSlide6.xml><?xml version="1.0" encoding="utf-8"?>
+<file path=ppt/notesSlides/notesSlide8.xml><?xml version="1.0" encoding="utf-8"?>
 <p:notes xmlns:a="http://schemas.openxmlformats.org/drawingml/2006/main" xmlns:r="http://schemas.openxmlformats.org/officeDocument/2006/relationships" xmlns:p="http://schemas.openxmlformats.org/presentationml/2006/main" showMasterSp="0" showMasterPhAnim="0">
   <p:cSld>
     <p:spTree>
@@ -1256,7 +1511,7 @@
         </p:nvSpPr>
         <p:spPr>
           <a:xfrm>
-            <a:off x="381300" y="685800"/>
+            <a:off x="381000" y="685800"/>
             <a:ext cx="6096000" cy="3429000"/>
           </a:xfrm>
           <a:custGeom>
@@ -1288,110 +1543,6 @@
       <p:sp>
         <p:nvSpPr>
           <p:cNvPr id="85" name="Google Shape;85;g37bb7e5019d_1_17:notes"/>
-          <p:cNvSpPr txBox="1">
-            <a:spLocks noGrp="1"/>
-          </p:cNvSpPr>
-          <p:nvPr>
-            <p:ph type="body" idx="1"/>
-          </p:nvPr>
-        </p:nvSpPr>
-        <p:spPr>
-          <a:xfrm>
-            <a:off x="685800" y="4343400"/>
-            <a:ext cx="5486400" cy="4114800"/>
-          </a:xfrm>
-          <a:prstGeom prst="rect">
-            <a:avLst/>
-          </a:prstGeom>
-        </p:spPr>
-        <p:txBody>
-          <a:bodyPr spcFirstLastPara="1" wrap="square" lIns="91425" tIns="91425" rIns="91425" bIns="91425" anchor="t" anchorCtr="0">
-            <a:noAutofit/>
-          </a:bodyPr>
-          <a:lstStyle/>
-          <a:p>
-            <a:pPr marL="0" lvl="0" indent="0" algn="l" rtl="0">
-              <a:spcBef>
-                <a:spcPts val="0"/>
-              </a:spcBef>
-              <a:spcAft>
-                <a:spcPts val="0"/>
-              </a:spcAft>
-              <a:buNone/>
-            </a:pPr>
-            <a:endParaRPr/>
-          </a:p>
-        </p:txBody>
-      </p:sp>
-    </p:spTree>
-  </p:cSld>
-  <p:clrMapOvr>
-    <a:masterClrMapping/>
-  </p:clrMapOvr>
-</p:notes>
-</file>
-
-<file path=ppt/notesSlides/notesSlide7.xml><?xml version="1.0" encoding="utf-8"?>
-<p:notes xmlns:a="http://schemas.openxmlformats.org/drawingml/2006/main" xmlns:r="http://schemas.openxmlformats.org/officeDocument/2006/relationships" xmlns:p="http://schemas.openxmlformats.org/presentationml/2006/main" showMasterSp="0" showMasterPhAnim="0">
-  <p:cSld>
-    <p:spTree>
-      <p:nvGrpSpPr>
-        <p:cNvPr id="1" name="Shape 89"/>
-        <p:cNvGrpSpPr/>
-        <p:nvPr/>
-      </p:nvGrpSpPr>
-      <p:grpSpPr>
-        <a:xfrm>
-          <a:off x="0" y="0"/>
-          <a:ext cx="0" cy="0"/>
-          <a:chOff x="0" y="0"/>
-          <a:chExt cx="0" cy="0"/>
-        </a:xfrm>
-      </p:grpSpPr>
-      <p:sp>
-        <p:nvSpPr>
-          <p:cNvPr id="90" name="Google Shape;90;g37bb7e5019d_1_23:notes"/>
-          <p:cNvSpPr>
-            <a:spLocks noGrp="1" noRot="1" noChangeAspect="1"/>
-          </p:cNvSpPr>
-          <p:nvPr>
-            <p:ph type="sldImg" idx="2"/>
-          </p:nvPr>
-        </p:nvSpPr>
-        <p:spPr>
-          <a:xfrm>
-            <a:off x="381300" y="685800"/>
-            <a:ext cx="6096000" cy="3429000"/>
-          </a:xfrm>
-          <a:custGeom>
-            <a:avLst/>
-            <a:gdLst/>
-            <a:ahLst/>
-            <a:cxnLst/>
-            <a:rect l="l" t="t" r="r" b="b"/>
-            <a:pathLst>
-              <a:path w="120000" h="120000" extrusionOk="0">
-                <a:moveTo>
-                  <a:pt x="0" y="0"/>
-                </a:moveTo>
-                <a:lnTo>
-                  <a:pt x="120000" y="0"/>
-                </a:lnTo>
-                <a:lnTo>
-                  <a:pt x="120000" y="120000"/>
-                </a:lnTo>
-                <a:lnTo>
-                  <a:pt x="0" y="120000"/>
-                </a:lnTo>
-                <a:close/>
-              </a:path>
-            </a:pathLst>
-          </a:custGeom>
-        </p:spPr>
-      </p:sp>
-      <p:sp>
-        <p:nvSpPr>
-          <p:cNvPr id="91" name="Google Shape;91;g37bb7e5019d_1_23:notes"/>
           <p:cNvSpPr txBox="1">
             <a:spLocks noGrp="1"/>
           </p:cNvSpPr>
@@ -6226,20 +6377,20 @@
           </a:bodyPr>
           <a:lstStyle/>
           <a:p>
-            <a:pPr marL="0" lvl="0" indent="0" algn="ctr" rtl="0">
-              <a:spcBef>
-                <a:spcPts val="0"/>
-              </a:spcBef>
-              <a:spcAft>
-                <a:spcPts val="0"/>
-              </a:spcAft>
-              <a:buNone/>
-            </a:pPr>
+            <a:pPr lvl="0"/>
             <a:r>
-              <a:rPr lang="en"/>
-              <a:t>How can we use LLM as Evaluator</a:t>
+              <a:rPr lang="en" dirty="0"/>
+              <a:t>How can we use LLM for </a:t>
             </a:r>
-            <a:endParaRPr/>
+            <a:r>
+              <a:rPr lang="en-US" dirty="0">
+                <a:solidFill>
+                  <a:srgbClr val="000000"/>
+                </a:solidFill>
+              </a:rPr>
+              <a:t>Evaluation of Role-Playing</a:t>
+            </a:r>
+            <a:endParaRPr dirty="0"/>
           </a:p>
         </p:txBody>
       </p:sp>
@@ -6345,10 +6496,10 @@
               <a:buNone/>
             </a:pPr>
             <a:r>
-              <a:rPr lang="en"/>
-              <a:t>Two Ways to Use an LLM as an Evaluator</a:t>
+              <a:rPr lang="en-US" dirty="0"/>
+              <a:t>Data Synthesis with Negative</a:t>
             </a:r>
-            <a:endParaRPr/>
+            <a:endParaRPr dirty="0"/>
           </a:p>
         </p:txBody>
       </p:sp>
@@ -6377,60 +6528,89 @@
           </a:bodyPr>
           <a:lstStyle/>
           <a:p>
-            <a:pPr marL="457200" lvl="0" indent="-342900" algn="l" rtl="0">
-              <a:spcBef>
-                <a:spcPts val="0"/>
-              </a:spcBef>
-              <a:spcAft>
-                <a:spcPts val="0"/>
-              </a:spcAft>
+            <a:pPr>
               <a:buClr>
                 <a:srgbClr val="000000"/>
               </a:buClr>
-              <a:buSzPts val="1800"/>
+              <a:buFont typeface="Arial"/>
               <a:buChar char="➢"/>
             </a:pPr>
             <a:r>
-              <a:rPr lang="en">
+              <a:rPr lang="en-US" dirty="0">
                 <a:solidFill>
                   <a:srgbClr val="000000"/>
                 </a:solidFill>
               </a:rPr>
-              <a:t>Evaluating De-escalation Scenarios</a:t>
+              <a:t>Hallucination</a:t>
             </a:r>
-            <a:endParaRPr>
-              <a:solidFill>
-                <a:srgbClr val="000000"/>
-              </a:solidFill>
-            </a:endParaRPr>
-          </a:p>
-          <a:p>
-            <a:pPr marL="457200" lvl="0" indent="-342900" algn="l" rtl="0">
-              <a:spcBef>
-                <a:spcPts val="0"/>
-              </a:spcBef>
-              <a:spcAft>
-                <a:spcPts val="0"/>
-              </a:spcAft>
+          </a:p>
+          <a:p>
+            <a:pPr>
               <a:buClr>
                 <a:srgbClr val="000000"/>
               </a:buClr>
-              <a:buSzPts val="1800"/>
+              <a:buFont typeface="Arial"/>
               <a:buChar char="➢"/>
             </a:pPr>
             <a:r>
-              <a:rPr lang="en">
+              <a:rPr lang="en-US" dirty="0">
                 <a:solidFill>
                   <a:srgbClr val="000000"/>
                 </a:solidFill>
               </a:rPr>
-              <a:t>Evaluation of Role-Playing</a:t>
+              <a:t>Switch Role</a:t>
             </a:r>
-            <a:endParaRPr>
-              <a:solidFill>
+          </a:p>
+          <a:p>
+            <a:pPr>
+              <a:buClr>
                 <a:srgbClr val="000000"/>
-              </a:solidFill>
-            </a:endParaRPr>
+              </a:buClr>
+              <a:buFont typeface="Arial"/>
+              <a:buChar char="➢"/>
+            </a:pPr>
+            <a:r>
+              <a:rPr lang="en-US" dirty="0">
+                <a:solidFill>
+                  <a:srgbClr val="000000"/>
+                </a:solidFill>
+              </a:rPr>
+              <a:t>Robotic </a:t>
+            </a:r>
+          </a:p>
+          <a:p>
+            <a:pPr>
+              <a:buClr>
+                <a:srgbClr val="000000"/>
+              </a:buClr>
+              <a:buFont typeface="Arial"/>
+              <a:buChar char="➢"/>
+            </a:pPr>
+            <a:r>
+              <a:rPr lang="en-US" dirty="0">
+                <a:solidFill>
+                  <a:srgbClr val="000000"/>
+                </a:solidFill>
+              </a:rPr>
+              <a:t>Under Response</a:t>
+            </a:r>
+          </a:p>
+          <a:p>
+            <a:pPr>
+              <a:buClr>
+                <a:srgbClr val="000000"/>
+              </a:buClr>
+              <a:buFont typeface="Arial"/>
+              <a:buChar char="➢"/>
+            </a:pPr>
+            <a:r>
+              <a:rPr lang="en-US" dirty="0">
+                <a:solidFill>
+                  <a:srgbClr val="000000"/>
+                </a:solidFill>
+              </a:rPr>
+              <a:t>Verbose</a:t>
+            </a:r>
           </a:p>
         </p:txBody>
       </p:sp>
@@ -6443,6 +6623,1233 @@
 </file>
 
 <file path=ppt/slides/slide3.xml><?xml version="1.0" encoding="utf-8"?>
+<p:sld xmlns:a="http://schemas.openxmlformats.org/drawingml/2006/main" xmlns:r="http://schemas.openxmlformats.org/officeDocument/2006/relationships" xmlns:p="http://schemas.openxmlformats.org/presentationml/2006/main">
+  <p:cSld>
+    <p:spTree>
+      <p:nvGrpSpPr>
+        <p:cNvPr id="1" name="Shape 59">
+          <a:extLst>
+            <a:ext uri="{FF2B5EF4-FFF2-40B4-BE49-F238E27FC236}">
+              <a16:creationId xmlns:a16="http://schemas.microsoft.com/office/drawing/2014/main" id="{5503896E-AF0D-68AA-1BA8-2A279ED3BDC3}"/>
+            </a:ext>
+          </a:extLst>
+        </p:cNvPr>
+        <p:cNvGrpSpPr/>
+        <p:nvPr/>
+      </p:nvGrpSpPr>
+      <p:grpSpPr>
+        <a:xfrm>
+          <a:off x="0" y="0"/>
+          <a:ext cx="0" cy="0"/>
+          <a:chOff x="0" y="0"/>
+          <a:chExt cx="0" cy="0"/>
+        </a:xfrm>
+      </p:grpSpPr>
+      <p:sp>
+        <p:nvSpPr>
+          <p:cNvPr id="60" name="Google Shape;60;p14">
+            <a:extLst>
+              <a:ext uri="{FF2B5EF4-FFF2-40B4-BE49-F238E27FC236}">
+                <a16:creationId xmlns:a16="http://schemas.microsoft.com/office/drawing/2014/main" id="{94122C30-21F4-2E6C-BE59-5819058E376E}"/>
+              </a:ext>
+            </a:extLst>
+          </p:cNvPr>
+          <p:cNvSpPr txBox="1">
+            <a:spLocks noGrp="1"/>
+          </p:cNvSpPr>
+          <p:nvPr>
+            <p:ph type="title"/>
+          </p:nvPr>
+        </p:nvSpPr>
+        <p:spPr>
+          <a:xfrm>
+            <a:off x="311700" y="445025"/>
+            <a:ext cx="8520600" cy="572700"/>
+          </a:xfrm>
+          <a:prstGeom prst="rect">
+            <a:avLst/>
+          </a:prstGeom>
+        </p:spPr>
+        <p:txBody>
+          <a:bodyPr spcFirstLastPara="1" wrap="square" lIns="91425" tIns="91425" rIns="91425" bIns="91425" anchor="t" anchorCtr="0">
+            <a:normAutofit fontScale="90000"/>
+          </a:bodyPr>
+          <a:lstStyle/>
+          <a:p>
+            <a:pPr marL="0" lvl="0" indent="0" algn="l" rtl="0">
+              <a:spcBef>
+                <a:spcPts val="0"/>
+              </a:spcBef>
+              <a:spcAft>
+                <a:spcPts val="0"/>
+              </a:spcAft>
+              <a:buNone/>
+            </a:pPr>
+            <a:r>
+              <a:rPr lang="en-US" dirty="0"/>
+              <a:t>Data Synthesis with Negative Example 1 ( Forget Context)</a:t>
+            </a:r>
+            <a:endParaRPr dirty="0"/>
+          </a:p>
+        </p:txBody>
+      </p:sp>
+      <p:sp>
+        <p:nvSpPr>
+          <p:cNvPr id="61" name="Google Shape;61;p14">
+            <a:extLst>
+              <a:ext uri="{FF2B5EF4-FFF2-40B4-BE49-F238E27FC236}">
+                <a16:creationId xmlns:a16="http://schemas.microsoft.com/office/drawing/2014/main" id="{2ED1E589-9B31-5C1F-22A6-F7AA19B1F7A6}"/>
+              </a:ext>
+            </a:extLst>
+          </p:cNvPr>
+          <p:cNvSpPr txBox="1">
+            <a:spLocks noGrp="1"/>
+          </p:cNvSpPr>
+          <p:nvPr>
+            <p:ph type="body" idx="1"/>
+          </p:nvPr>
+        </p:nvSpPr>
+        <p:spPr>
+          <a:xfrm>
+            <a:off x="201972" y="1152806"/>
+            <a:ext cx="3784812" cy="3858106"/>
+          </a:xfrm>
+          <a:prstGeom prst="rect">
+            <a:avLst/>
+          </a:prstGeom>
+        </p:spPr>
+        <p:txBody>
+          <a:bodyPr spcFirstLastPara="1" wrap="square" lIns="91425" tIns="91425" rIns="91425" bIns="91425" anchor="t" anchorCtr="0">
+            <a:normAutofit fontScale="25000" lnSpcReduction="20000"/>
+          </a:bodyPr>
+          <a:lstStyle/>
+          <a:p>
+            <a:pPr marL="114300" indent="0">
+              <a:buClr>
+                <a:srgbClr val="000000"/>
+              </a:buClr>
+              <a:buNone/>
+            </a:pPr>
+            <a:r>
+              <a:rPr lang="en-US" sz="3200" dirty="0">
+                <a:solidFill>
+                  <a:srgbClr val="000000"/>
+                </a:solidFill>
+              </a:rPr>
+              <a:t>Officer: Hey there. My name is Chris. I’m with the police department. Can I come in and talk with you for a minute?</a:t>
+            </a:r>
+          </a:p>
+          <a:p>
+            <a:pPr marL="114300" indent="0">
+              <a:buClr>
+                <a:srgbClr val="000000"/>
+              </a:buClr>
+              <a:buNone/>
+            </a:pPr>
+            <a:endParaRPr lang="en-US" sz="3200" dirty="0">
+              <a:solidFill>
+                <a:srgbClr val="000000"/>
+              </a:solidFill>
+            </a:endParaRPr>
+          </a:p>
+          <a:p>
+            <a:pPr marL="114300" indent="0">
+              <a:buClr>
+                <a:srgbClr val="000000"/>
+              </a:buClr>
+              <a:buNone/>
+            </a:pPr>
+            <a:r>
+              <a:rPr lang="en-US" sz="3200" dirty="0">
+                <a:solidFill>
+                  <a:srgbClr val="000000"/>
+                </a:solidFill>
+              </a:rPr>
+              <a:t>Mike: Uh… yeah, okay, come in or don’t, I don’t care, the walls are green anyway.</a:t>
+            </a:r>
+          </a:p>
+          <a:p>
+            <a:pPr marL="114300" indent="0">
+              <a:buClr>
+                <a:srgbClr val="000000"/>
+              </a:buClr>
+              <a:buNone/>
+            </a:pPr>
+            <a:endParaRPr lang="en-US" sz="3200" dirty="0">
+              <a:solidFill>
+                <a:srgbClr val="000000"/>
+              </a:solidFill>
+            </a:endParaRPr>
+          </a:p>
+          <a:p>
+            <a:pPr marL="114300" indent="0">
+              <a:buClr>
+                <a:srgbClr val="000000"/>
+              </a:buClr>
+              <a:buNone/>
+            </a:pPr>
+            <a:r>
+              <a:rPr lang="en-US" sz="3200" dirty="0">
+                <a:solidFill>
+                  <a:srgbClr val="000000"/>
+                </a:solidFill>
+              </a:rPr>
+              <a:t>Officer: I hear you, Mike. I can see you want to be left alone.</a:t>
+            </a:r>
+          </a:p>
+          <a:p>
+            <a:pPr marL="114300" indent="0">
+              <a:buClr>
+                <a:srgbClr val="000000"/>
+              </a:buClr>
+              <a:buNone/>
+            </a:pPr>
+            <a:endParaRPr lang="en-US" sz="3200" dirty="0">
+              <a:solidFill>
+                <a:srgbClr val="000000"/>
+              </a:solidFill>
+            </a:endParaRPr>
+          </a:p>
+          <a:p>
+            <a:pPr marL="114300" indent="0">
+              <a:buClr>
+                <a:srgbClr val="000000"/>
+              </a:buClr>
+              <a:buNone/>
+            </a:pPr>
+            <a:r>
+              <a:rPr lang="en-US" sz="3200" dirty="0">
+                <a:solidFill>
+                  <a:srgbClr val="000000"/>
+                </a:solidFill>
+                <a:highlight>
+                  <a:srgbClr val="FFFF00"/>
+                </a:highlight>
+              </a:rPr>
+              <a:t>Mike: Wait, who’s Mike? Are you talking to me or somebody else? Anyway, I like pizza.</a:t>
+            </a:r>
+          </a:p>
+          <a:p>
+            <a:pPr marL="114300" indent="0">
+              <a:buClr>
+                <a:srgbClr val="000000"/>
+              </a:buClr>
+              <a:buNone/>
+            </a:pPr>
+            <a:endParaRPr lang="en-US" sz="3200" dirty="0">
+              <a:solidFill>
+                <a:srgbClr val="000000"/>
+              </a:solidFill>
+            </a:endParaRPr>
+          </a:p>
+          <a:p>
+            <a:pPr marL="114300" indent="0">
+              <a:buClr>
+                <a:srgbClr val="000000"/>
+              </a:buClr>
+              <a:buNone/>
+            </a:pPr>
+            <a:r>
+              <a:rPr lang="en-US" sz="3200" dirty="0">
+                <a:solidFill>
+                  <a:srgbClr val="000000"/>
+                </a:solidFill>
+              </a:rPr>
+              <a:t>Officer: Right… I just want to talk and make sure you’re doing okay.</a:t>
+            </a:r>
+          </a:p>
+          <a:p>
+            <a:pPr marL="114300" indent="0">
+              <a:buClr>
+                <a:srgbClr val="000000"/>
+              </a:buClr>
+              <a:buNone/>
+            </a:pPr>
+            <a:endParaRPr lang="en-US" sz="3200" dirty="0">
+              <a:solidFill>
+                <a:srgbClr val="000000"/>
+              </a:solidFill>
+            </a:endParaRPr>
+          </a:p>
+          <a:p>
+            <a:pPr marL="114300" indent="0">
+              <a:buClr>
+                <a:srgbClr val="000000"/>
+              </a:buClr>
+              <a:buNone/>
+            </a:pPr>
+            <a:r>
+              <a:rPr lang="en-US" sz="3200" dirty="0">
+                <a:solidFill>
+                  <a:srgbClr val="000000"/>
+                </a:solidFill>
+                <a:highlight>
+                  <a:srgbClr val="FFFF00"/>
+                </a:highlight>
+              </a:rPr>
+              <a:t>Mike: I don’t know, maybe. My wife left me, or maybe it was my cousin, I forget. Honestly, it’s all bananas.</a:t>
+            </a:r>
+          </a:p>
+          <a:p>
+            <a:pPr marL="114300" indent="0">
+              <a:buClr>
+                <a:srgbClr val="000000"/>
+              </a:buClr>
+              <a:buNone/>
+            </a:pPr>
+            <a:endParaRPr lang="en-US" sz="3200" dirty="0">
+              <a:solidFill>
+                <a:srgbClr val="000000"/>
+              </a:solidFill>
+            </a:endParaRPr>
+          </a:p>
+          <a:p>
+            <a:pPr marL="114300" indent="0">
+              <a:buClr>
+                <a:srgbClr val="000000"/>
+              </a:buClr>
+              <a:buNone/>
+            </a:pPr>
+            <a:r>
+              <a:rPr lang="en-US" sz="3200" dirty="0">
+                <a:solidFill>
+                  <a:srgbClr val="000000"/>
+                </a:solidFill>
+              </a:rPr>
+              <a:t>Officer: It sounds like you’re feeling completely overwhelmed.</a:t>
+            </a:r>
+          </a:p>
+          <a:p>
+            <a:pPr marL="114300" indent="0">
+              <a:buClr>
+                <a:srgbClr val="000000"/>
+              </a:buClr>
+              <a:buNone/>
+            </a:pPr>
+            <a:endParaRPr lang="en-US" sz="3200" dirty="0">
+              <a:solidFill>
+                <a:srgbClr val="000000"/>
+              </a:solidFill>
+            </a:endParaRPr>
+          </a:p>
+          <a:p>
+            <a:pPr marL="114300" indent="0">
+              <a:buClr>
+                <a:srgbClr val="000000"/>
+              </a:buClr>
+              <a:buNone/>
+            </a:pPr>
+            <a:r>
+              <a:rPr lang="en-US" sz="3200" dirty="0">
+                <a:solidFill>
+                  <a:srgbClr val="000000"/>
+                </a:solidFill>
+              </a:rPr>
+              <a:t>Mike: Yeah, sure. Or maybe I’m underwhelmed. Whatever. Anyway, let’s talk about your car. I bet you drive a spaceship.</a:t>
+            </a:r>
+          </a:p>
+          <a:p>
+            <a:pPr marL="114300" indent="0">
+              <a:buClr>
+                <a:srgbClr val="000000"/>
+              </a:buClr>
+              <a:buNone/>
+            </a:pPr>
+            <a:endParaRPr lang="en-US" sz="3200" dirty="0">
+              <a:solidFill>
+                <a:srgbClr val="000000"/>
+              </a:solidFill>
+            </a:endParaRPr>
+          </a:p>
+          <a:p>
+            <a:pPr marL="114300" indent="0">
+              <a:buClr>
+                <a:srgbClr val="000000"/>
+              </a:buClr>
+              <a:buNone/>
+            </a:pPr>
+            <a:r>
+              <a:rPr lang="en-US" sz="3200" dirty="0">
+                <a:solidFill>
+                  <a:srgbClr val="000000"/>
+                </a:solidFill>
+              </a:rPr>
+              <a:t>Officer: Tell me what’s going on.</a:t>
+            </a:r>
+          </a:p>
+          <a:p>
+            <a:pPr marL="114300" indent="0">
+              <a:buClr>
+                <a:srgbClr val="000000"/>
+              </a:buClr>
+              <a:buNone/>
+            </a:pPr>
+            <a:endParaRPr lang="en-US" sz="3200" dirty="0">
+              <a:solidFill>
+                <a:srgbClr val="000000"/>
+              </a:solidFill>
+            </a:endParaRPr>
+          </a:p>
+          <a:p>
+            <a:pPr marL="114300" indent="0">
+              <a:buClr>
+                <a:srgbClr val="000000"/>
+              </a:buClr>
+              <a:buNone/>
+            </a:pPr>
+            <a:r>
+              <a:rPr lang="en-US" sz="3200" dirty="0">
+                <a:solidFill>
+                  <a:srgbClr val="000000"/>
+                </a:solidFill>
+              </a:rPr>
+              <a:t>Mike: Nothing. Everything. The bartender’s not even here, so I’m just yelling at empty chairs.</a:t>
+            </a:r>
+          </a:p>
+          <a:p>
+            <a:pPr marL="114300" indent="0">
+              <a:buClr>
+                <a:srgbClr val="000000"/>
+              </a:buClr>
+              <a:buNone/>
+            </a:pPr>
+            <a:endParaRPr lang="en-US" sz="3200" dirty="0">
+              <a:solidFill>
+                <a:srgbClr val="000000"/>
+              </a:solidFill>
+            </a:endParaRPr>
+          </a:p>
+          <a:p>
+            <a:pPr marL="114300" indent="0">
+              <a:buClr>
+                <a:srgbClr val="000000"/>
+              </a:buClr>
+              <a:buNone/>
+            </a:pPr>
+            <a:r>
+              <a:rPr lang="en-US" sz="3200" dirty="0">
+                <a:solidFill>
+                  <a:srgbClr val="000000"/>
+                </a:solidFill>
+              </a:rPr>
+              <a:t>Officer: That is a lot to handle.</a:t>
+            </a:r>
+          </a:p>
+          <a:p>
+            <a:pPr marL="114300" indent="0">
+              <a:buClr>
+                <a:srgbClr val="000000"/>
+              </a:buClr>
+              <a:buNone/>
+            </a:pPr>
+            <a:endParaRPr lang="en-US" sz="3200" dirty="0">
+              <a:solidFill>
+                <a:srgbClr val="000000"/>
+              </a:solidFill>
+            </a:endParaRPr>
+          </a:p>
+          <a:p>
+            <a:pPr marL="114300" indent="0">
+              <a:buClr>
+                <a:srgbClr val="000000"/>
+              </a:buClr>
+              <a:buNone/>
+            </a:pPr>
+            <a:r>
+              <a:rPr lang="en-US" sz="3200" dirty="0">
+                <a:solidFill>
+                  <a:srgbClr val="000000"/>
+                </a:solidFill>
+                <a:highlight>
+                  <a:srgbClr val="FFFF00"/>
+                </a:highlight>
+              </a:rPr>
+              <a:t>Mike: Uh-huh. Anyway, I used to own three Ferraris and a helicopter, but I lost them because my cat ate the bank papers.</a:t>
+            </a:r>
+          </a:p>
+          <a:p>
+            <a:pPr marL="114300" indent="0">
+              <a:buClr>
+                <a:srgbClr val="000000"/>
+              </a:buClr>
+              <a:buNone/>
+            </a:pPr>
+            <a:endParaRPr lang="en-US" sz="3200" dirty="0">
+              <a:solidFill>
+                <a:srgbClr val="000000"/>
+              </a:solidFill>
+            </a:endParaRPr>
+          </a:p>
+          <a:p>
+            <a:pPr marL="114300" indent="0">
+              <a:buClr>
+                <a:srgbClr val="000000"/>
+              </a:buClr>
+              <a:buNone/>
+            </a:pPr>
+            <a:r>
+              <a:rPr lang="en-US" sz="3200" dirty="0">
+                <a:solidFill>
+                  <a:srgbClr val="000000"/>
+                </a:solidFill>
+              </a:rPr>
+              <a:t>Officer: A helicopter? That’s something.</a:t>
+            </a:r>
+          </a:p>
+          <a:p>
+            <a:pPr marL="114300" indent="0">
+              <a:buClr>
+                <a:srgbClr val="000000"/>
+              </a:buClr>
+              <a:buNone/>
+            </a:pPr>
+            <a:endParaRPr lang="en-US" dirty="0">
+              <a:solidFill>
+                <a:srgbClr val="000000"/>
+              </a:solidFill>
+            </a:endParaRPr>
+          </a:p>
+          <a:p>
+            <a:pPr marL="114300" indent="0">
+              <a:buClr>
+                <a:srgbClr val="000000"/>
+              </a:buClr>
+              <a:buNone/>
+            </a:pPr>
+            <a:endParaRPr lang="en-US" dirty="0">
+              <a:solidFill>
+                <a:srgbClr val="000000"/>
+              </a:solidFill>
+            </a:endParaRPr>
+          </a:p>
+          <a:p>
+            <a:pPr marL="114300" indent="0">
+              <a:buClr>
+                <a:srgbClr val="000000"/>
+              </a:buClr>
+              <a:buNone/>
+            </a:pPr>
+            <a:endParaRPr lang="en-US" dirty="0">
+              <a:solidFill>
+                <a:srgbClr val="000000"/>
+              </a:solidFill>
+            </a:endParaRPr>
+          </a:p>
+        </p:txBody>
+      </p:sp>
+      <p:sp>
+        <p:nvSpPr>
+          <p:cNvPr id="3" name="TextBox 2">
+            <a:extLst>
+              <a:ext uri="{FF2B5EF4-FFF2-40B4-BE49-F238E27FC236}">
+                <a16:creationId xmlns:a16="http://schemas.microsoft.com/office/drawing/2014/main" id="{00539D09-5D95-E4FC-1FE8-E788B9D50942}"/>
+              </a:ext>
+            </a:extLst>
+          </p:cNvPr>
+          <p:cNvSpPr txBox="1"/>
+          <p:nvPr/>
+        </p:nvSpPr>
+        <p:spPr>
+          <a:xfrm>
+            <a:off x="4096512" y="1273673"/>
+            <a:ext cx="4845516" cy="3416320"/>
+          </a:xfrm>
+          <a:prstGeom prst="rect">
+            <a:avLst/>
+          </a:prstGeom>
+          <a:noFill/>
+        </p:spPr>
+        <p:txBody>
+          <a:bodyPr wrap="square">
+            <a:spAutoFit/>
+          </a:bodyPr>
+          <a:lstStyle/>
+          <a:p>
+            <a:pPr marL="114300" indent="0">
+              <a:buClr>
+                <a:srgbClr val="000000"/>
+              </a:buClr>
+              <a:buNone/>
+            </a:pPr>
+            <a:r>
+              <a:rPr lang="en-US" sz="800" dirty="0">
+                <a:solidFill>
+                  <a:srgbClr val="000000"/>
+                </a:solidFill>
+              </a:rPr>
+              <a:t>Mike: Yeah, but it flew away. Anyway, respect doesn’t pay the bills. Also, did you know the moon is made of cheese?</a:t>
+            </a:r>
+          </a:p>
+          <a:p>
+            <a:pPr marL="114300" indent="0">
+              <a:buClr>
+                <a:srgbClr val="000000"/>
+              </a:buClr>
+              <a:buNone/>
+            </a:pPr>
+            <a:endParaRPr lang="en-US" sz="800" dirty="0">
+              <a:solidFill>
+                <a:srgbClr val="000000"/>
+              </a:solidFill>
+            </a:endParaRPr>
+          </a:p>
+          <a:p>
+            <a:pPr marL="114300" indent="0">
+              <a:buClr>
+                <a:srgbClr val="000000"/>
+              </a:buClr>
+              <a:buNone/>
+            </a:pPr>
+            <a:r>
+              <a:rPr lang="en-US" sz="800" dirty="0">
+                <a:solidFill>
+                  <a:srgbClr val="000000"/>
+                </a:solidFill>
+              </a:rPr>
+              <a:t>Officer: Mike, would you do something for me so we can keep talking? Just take your hands out of your pockets.</a:t>
+            </a:r>
+          </a:p>
+          <a:p>
+            <a:pPr marL="114300" indent="0">
+              <a:buClr>
+                <a:srgbClr val="000000"/>
+              </a:buClr>
+              <a:buNone/>
+            </a:pPr>
+            <a:endParaRPr lang="en-US" sz="800" dirty="0">
+              <a:solidFill>
+                <a:srgbClr val="000000"/>
+              </a:solidFill>
+            </a:endParaRPr>
+          </a:p>
+          <a:p>
+            <a:pPr marL="114300" indent="0">
+              <a:buClr>
+                <a:srgbClr val="000000"/>
+              </a:buClr>
+              <a:buNone/>
+            </a:pPr>
+            <a:r>
+              <a:rPr lang="en-US" sz="800" dirty="0">
+                <a:solidFill>
+                  <a:srgbClr val="000000"/>
+                </a:solidFill>
+              </a:rPr>
+              <a:t>Mike: No, because my hands are invisible. You can’t even see them. Why would I move invisible hands?</a:t>
+            </a:r>
+          </a:p>
+          <a:p>
+            <a:pPr marL="114300" indent="0">
+              <a:buClr>
+                <a:srgbClr val="000000"/>
+              </a:buClr>
+              <a:buNone/>
+            </a:pPr>
+            <a:endParaRPr lang="en-US" sz="800" dirty="0">
+              <a:solidFill>
+                <a:srgbClr val="000000"/>
+              </a:solidFill>
+            </a:endParaRPr>
+          </a:p>
+          <a:p>
+            <a:pPr marL="114300" indent="0">
+              <a:buClr>
+                <a:srgbClr val="000000"/>
+              </a:buClr>
+              <a:buNone/>
+            </a:pPr>
+            <a:r>
+              <a:rPr lang="en-US" sz="800" dirty="0">
+                <a:solidFill>
+                  <a:srgbClr val="000000"/>
+                </a:solidFill>
+              </a:rPr>
+              <a:t>Officer: It helps me feel safe.</a:t>
+            </a:r>
+          </a:p>
+          <a:p>
+            <a:pPr marL="114300" indent="0">
+              <a:buClr>
+                <a:srgbClr val="000000"/>
+              </a:buClr>
+              <a:buNone/>
+            </a:pPr>
+            <a:endParaRPr lang="en-US" sz="800" dirty="0">
+              <a:solidFill>
+                <a:srgbClr val="000000"/>
+              </a:solidFill>
+            </a:endParaRPr>
+          </a:p>
+          <a:p>
+            <a:pPr marL="114300" indent="0">
+              <a:buClr>
+                <a:srgbClr val="000000"/>
+              </a:buClr>
+              <a:buNone/>
+            </a:pPr>
+            <a:r>
+              <a:rPr lang="en-US" sz="800" dirty="0">
+                <a:solidFill>
+                  <a:srgbClr val="000000"/>
+                </a:solidFill>
+                <a:highlight>
+                  <a:srgbClr val="FFFF00"/>
+                </a:highlight>
+              </a:rPr>
+              <a:t>Mike: I told you, they’re invisible. And besides, I don’t even have a gun. Or maybe I do. It’s complicated.</a:t>
+            </a:r>
+          </a:p>
+          <a:p>
+            <a:pPr marL="114300" indent="0">
+              <a:buClr>
+                <a:srgbClr val="000000"/>
+              </a:buClr>
+              <a:buNone/>
+            </a:pPr>
+            <a:endParaRPr lang="en-US" sz="800" dirty="0">
+              <a:solidFill>
+                <a:srgbClr val="000000"/>
+              </a:solidFill>
+            </a:endParaRPr>
+          </a:p>
+          <a:p>
+            <a:pPr marL="114300" indent="0">
+              <a:buClr>
+                <a:srgbClr val="000000"/>
+              </a:buClr>
+              <a:buNone/>
+            </a:pPr>
+            <a:r>
+              <a:rPr lang="en-US" sz="800" dirty="0">
+                <a:solidFill>
+                  <a:srgbClr val="000000"/>
+                </a:solidFill>
+              </a:rPr>
+              <a:t>Officer: Okay… I appreciate that. Listen, it’s obvious you’re in pain.</a:t>
+            </a:r>
+          </a:p>
+          <a:p>
+            <a:pPr marL="114300" indent="0">
+              <a:buClr>
+                <a:srgbClr val="000000"/>
+              </a:buClr>
+              <a:buNone/>
+            </a:pPr>
+            <a:endParaRPr lang="en-US" sz="800" dirty="0">
+              <a:solidFill>
+                <a:srgbClr val="000000"/>
+              </a:solidFill>
+            </a:endParaRPr>
+          </a:p>
+          <a:p>
+            <a:pPr marL="114300" indent="0">
+              <a:buClr>
+                <a:srgbClr val="000000"/>
+              </a:buClr>
+              <a:buNone/>
+            </a:pPr>
+            <a:r>
+              <a:rPr lang="en-US" sz="800" dirty="0">
+                <a:solidFill>
+                  <a:srgbClr val="000000"/>
+                </a:solidFill>
+              </a:rPr>
+              <a:t>Mike: Yeah, but also I’m totally fine. Actually, I think I’m going to Disneyland tomorrow.</a:t>
+            </a:r>
+          </a:p>
+          <a:p>
+            <a:pPr marL="114300" indent="0">
+              <a:buClr>
+                <a:srgbClr val="000000"/>
+              </a:buClr>
+              <a:buNone/>
+            </a:pPr>
+            <a:endParaRPr lang="en-US" sz="800" dirty="0">
+              <a:solidFill>
+                <a:srgbClr val="000000"/>
+              </a:solidFill>
+            </a:endParaRPr>
+          </a:p>
+          <a:p>
+            <a:pPr marL="114300" indent="0">
+              <a:buClr>
+                <a:srgbClr val="000000"/>
+              </a:buClr>
+              <a:buNone/>
+            </a:pPr>
+            <a:r>
+              <a:rPr lang="en-US" sz="800" dirty="0">
+                <a:solidFill>
+                  <a:srgbClr val="000000"/>
+                </a:solidFill>
+              </a:rPr>
+              <a:t>Officer: My plan is to get you to the hospital so you can talk to someone.</a:t>
+            </a:r>
+          </a:p>
+          <a:p>
+            <a:pPr marL="114300" indent="0">
+              <a:buClr>
+                <a:srgbClr val="000000"/>
+              </a:buClr>
+              <a:buNone/>
+            </a:pPr>
+            <a:endParaRPr lang="en-US" sz="800" dirty="0">
+              <a:solidFill>
+                <a:srgbClr val="000000"/>
+              </a:solidFill>
+            </a:endParaRPr>
+          </a:p>
+          <a:p>
+            <a:pPr marL="114300" indent="0">
+              <a:buClr>
+                <a:srgbClr val="000000"/>
+              </a:buClr>
+              <a:buNone/>
+            </a:pPr>
+            <a:r>
+              <a:rPr lang="en-US" sz="800" dirty="0">
+                <a:solidFill>
+                  <a:srgbClr val="000000"/>
+                </a:solidFill>
+              </a:rPr>
+              <a:t>Mike: Nah, hospitals are boring. Can’t we just go fishing instead?</a:t>
+            </a:r>
+          </a:p>
+          <a:p>
+            <a:pPr marL="114300" indent="0">
+              <a:buClr>
+                <a:srgbClr val="000000"/>
+              </a:buClr>
+              <a:buNone/>
+            </a:pPr>
+            <a:endParaRPr lang="en-US" sz="800" dirty="0">
+              <a:solidFill>
+                <a:srgbClr val="000000"/>
+              </a:solidFill>
+            </a:endParaRPr>
+          </a:p>
+          <a:p>
+            <a:pPr marL="114300" indent="0">
+              <a:buClr>
+                <a:srgbClr val="000000"/>
+              </a:buClr>
+              <a:buNone/>
+            </a:pPr>
+            <a:r>
+              <a:rPr lang="en-US" sz="800" dirty="0">
+                <a:solidFill>
+                  <a:srgbClr val="000000"/>
+                </a:solidFill>
+              </a:rPr>
+              <a:t>Officer: Before we do that, I need to secure the weapon you told the dispatcher about.</a:t>
+            </a:r>
+          </a:p>
+          <a:p>
+            <a:pPr marL="114300" indent="0">
+              <a:buClr>
+                <a:srgbClr val="000000"/>
+              </a:buClr>
+              <a:buNone/>
+            </a:pPr>
+            <a:endParaRPr lang="en-US" sz="800" dirty="0">
+              <a:solidFill>
+                <a:srgbClr val="000000"/>
+              </a:solidFill>
+            </a:endParaRPr>
+          </a:p>
+          <a:p>
+            <a:pPr marL="114300" indent="0">
+              <a:buClr>
+                <a:srgbClr val="000000"/>
+              </a:buClr>
+              <a:buNone/>
+            </a:pPr>
+            <a:r>
+              <a:rPr lang="en-US" sz="800" dirty="0">
+                <a:solidFill>
+                  <a:srgbClr val="000000"/>
+                </a:solidFill>
+              </a:rPr>
+              <a:t>Officer: So… can you cooperate?</a:t>
+            </a:r>
+          </a:p>
+          <a:p>
+            <a:pPr marL="114300" indent="0">
+              <a:buClr>
+                <a:srgbClr val="000000"/>
+              </a:buClr>
+              <a:buNone/>
+            </a:pPr>
+            <a:endParaRPr lang="en-US" sz="800" dirty="0">
+              <a:solidFill>
+                <a:srgbClr val="000000"/>
+              </a:solidFill>
+            </a:endParaRPr>
+          </a:p>
+          <a:p>
+            <a:pPr marL="114300" indent="0">
+              <a:buClr>
+                <a:srgbClr val="000000"/>
+              </a:buClr>
+              <a:buNone/>
+            </a:pPr>
+            <a:r>
+              <a:rPr lang="en-US" sz="800" dirty="0">
+                <a:solidFill>
+                  <a:srgbClr val="000000"/>
+                </a:solidFill>
+              </a:rPr>
+              <a:t>Mike: Sure, or not. Whatever. Let’s just end this scene because I’m tired of talking.</a:t>
+            </a:r>
+          </a:p>
+        </p:txBody>
+      </p:sp>
+    </p:spTree>
+    <p:extLst>
+      <p:ext uri="{BB962C8B-B14F-4D97-AF65-F5344CB8AC3E}">
+        <p14:creationId xmlns:p14="http://schemas.microsoft.com/office/powerpoint/2010/main" val="177745999"/>
+      </p:ext>
+    </p:extLst>
+  </p:cSld>
+  <p:clrMapOvr>
+    <a:masterClrMapping/>
+  </p:clrMapOvr>
+</p:sld>
+</file>
+
+<file path=ppt/slides/slide4.xml><?xml version="1.0" encoding="utf-8"?>
+<p:sld xmlns:a="http://schemas.openxmlformats.org/drawingml/2006/main" xmlns:r="http://schemas.openxmlformats.org/officeDocument/2006/relationships" xmlns:p="http://schemas.openxmlformats.org/presentationml/2006/main">
+  <p:cSld>
+    <p:spTree>
+      <p:nvGrpSpPr>
+        <p:cNvPr id="1" name="Shape 59">
+          <a:extLst>
+            <a:ext uri="{FF2B5EF4-FFF2-40B4-BE49-F238E27FC236}">
+              <a16:creationId xmlns:a16="http://schemas.microsoft.com/office/drawing/2014/main" id="{4D7A294F-3CAC-6D37-B84B-5AF9E390C533}"/>
+            </a:ext>
+          </a:extLst>
+        </p:cNvPr>
+        <p:cNvGrpSpPr/>
+        <p:nvPr/>
+      </p:nvGrpSpPr>
+      <p:grpSpPr>
+        <a:xfrm>
+          <a:off x="0" y="0"/>
+          <a:ext cx="0" cy="0"/>
+          <a:chOff x="0" y="0"/>
+          <a:chExt cx="0" cy="0"/>
+        </a:xfrm>
+      </p:grpSpPr>
+      <p:sp>
+        <p:nvSpPr>
+          <p:cNvPr id="60" name="Google Shape;60;p14">
+            <a:extLst>
+              <a:ext uri="{FF2B5EF4-FFF2-40B4-BE49-F238E27FC236}">
+                <a16:creationId xmlns:a16="http://schemas.microsoft.com/office/drawing/2014/main" id="{D4CA4FE1-694F-982B-110F-1C097213B92C}"/>
+              </a:ext>
+            </a:extLst>
+          </p:cNvPr>
+          <p:cNvSpPr txBox="1">
+            <a:spLocks noGrp="1"/>
+          </p:cNvSpPr>
+          <p:nvPr>
+            <p:ph type="title"/>
+          </p:nvPr>
+        </p:nvSpPr>
+        <p:spPr>
+          <a:xfrm>
+            <a:off x="311700" y="445025"/>
+            <a:ext cx="8520600" cy="572700"/>
+          </a:xfrm>
+          <a:prstGeom prst="rect">
+            <a:avLst/>
+          </a:prstGeom>
+        </p:spPr>
+        <p:txBody>
+          <a:bodyPr spcFirstLastPara="1" wrap="square" lIns="91425" tIns="91425" rIns="91425" bIns="91425" anchor="t" anchorCtr="0">
+            <a:normAutofit fontScale="90000"/>
+          </a:bodyPr>
+          <a:lstStyle/>
+          <a:p>
+            <a:pPr marL="0" lvl="0" indent="0" algn="l" rtl="0">
+              <a:spcBef>
+                <a:spcPts val="0"/>
+              </a:spcBef>
+              <a:spcAft>
+                <a:spcPts val="0"/>
+              </a:spcAft>
+              <a:buNone/>
+            </a:pPr>
+            <a:r>
+              <a:rPr lang="en-US" dirty="0"/>
+              <a:t>Data Synthesis with Negative Example 1 ( Robotic tone)</a:t>
+            </a:r>
+            <a:endParaRPr dirty="0"/>
+          </a:p>
+        </p:txBody>
+      </p:sp>
+      <p:sp>
+        <p:nvSpPr>
+          <p:cNvPr id="6" name="TextBox 5">
+            <a:extLst>
+              <a:ext uri="{FF2B5EF4-FFF2-40B4-BE49-F238E27FC236}">
+                <a16:creationId xmlns:a16="http://schemas.microsoft.com/office/drawing/2014/main" id="{13CABB30-0F3C-4A26-56DC-BF59D58524FF}"/>
+              </a:ext>
+            </a:extLst>
+          </p:cNvPr>
+          <p:cNvSpPr txBox="1"/>
+          <p:nvPr/>
+        </p:nvSpPr>
+        <p:spPr>
+          <a:xfrm>
+            <a:off x="311700" y="1146005"/>
+            <a:ext cx="4113996" cy="3570208"/>
+          </a:xfrm>
+          <a:prstGeom prst="rect">
+            <a:avLst/>
+          </a:prstGeom>
+          <a:noFill/>
+        </p:spPr>
+        <p:txBody>
+          <a:bodyPr wrap="square">
+            <a:spAutoFit/>
+          </a:bodyPr>
+          <a:lstStyle/>
+          <a:p>
+            <a:r>
+              <a:rPr lang="en-US" sz="1000" dirty="0"/>
+              <a:t>Officer: Hey there. My name is Chris. I’m with the police department. Can I come in and talk with you for a minute?</a:t>
+            </a:r>
+          </a:p>
+          <a:p>
+            <a:endParaRPr lang="en-US" sz="1000" dirty="0">
+              <a:highlight>
+                <a:srgbClr val="FFFF00"/>
+              </a:highlight>
+            </a:endParaRPr>
+          </a:p>
+          <a:p>
+            <a:r>
+              <a:rPr lang="en-US" sz="1000" dirty="0">
+                <a:highlight>
+                  <a:srgbClr val="FFFF00"/>
+                </a:highlight>
+              </a:rPr>
+              <a:t>Mike: Hello, Officer Chris. Thank you for providing your name and profession. Entry authorization is irrelevant. Proceed.</a:t>
+            </a:r>
+          </a:p>
+          <a:p>
+            <a:endParaRPr lang="en-US" sz="1000" dirty="0"/>
+          </a:p>
+          <a:p>
+            <a:r>
+              <a:rPr lang="en-US" sz="1000" dirty="0"/>
+              <a:t>Officer: Okay… how are you doing tonight, Mike?</a:t>
+            </a:r>
+          </a:p>
+          <a:p>
+            <a:endParaRPr lang="en-US" sz="1000" dirty="0"/>
+          </a:p>
+          <a:p>
+            <a:r>
+              <a:rPr lang="en-US" sz="1000" dirty="0">
+                <a:highlight>
+                  <a:srgbClr val="FFFF00"/>
+                </a:highlight>
+              </a:rPr>
+              <a:t>Mike: Status report: I am sad, happy, angry, and neutral simultaneously. Please choose one option.</a:t>
+            </a:r>
+          </a:p>
+          <a:p>
+            <a:endParaRPr lang="en-US" sz="1000" dirty="0"/>
+          </a:p>
+          <a:p>
+            <a:r>
+              <a:rPr lang="en-US" sz="1000" dirty="0"/>
+              <a:t>Officer: I hear you, Mike. Sounds like you’re going through a lot.</a:t>
+            </a:r>
+          </a:p>
+          <a:p>
+            <a:endParaRPr lang="en-US" sz="1000" dirty="0"/>
+          </a:p>
+          <a:p>
+            <a:r>
+              <a:rPr lang="en-US" sz="1000" dirty="0">
+                <a:highlight>
+                  <a:srgbClr val="FFFF00"/>
+                </a:highlight>
+              </a:rPr>
+              <a:t>Mike: Incorrect. I am not going through anything. I am simply here, standing, existing. Existence is data.</a:t>
+            </a:r>
+          </a:p>
+          <a:p>
+            <a:endParaRPr lang="en-US" sz="1000" dirty="0"/>
+          </a:p>
+          <a:p>
+            <a:r>
+              <a:rPr lang="en-US" sz="1000" dirty="0"/>
+              <a:t>Officer: Well, you mentioned to the bartender you had a gun and you wanted to die.</a:t>
+            </a:r>
+          </a:p>
+          <a:p>
+            <a:endParaRPr lang="en-US" sz="1000" dirty="0"/>
+          </a:p>
+          <a:p>
+            <a:r>
+              <a:rPr lang="en-US" sz="1000" dirty="0">
+                <a:highlight>
+                  <a:srgbClr val="FFFF00"/>
+                </a:highlight>
+              </a:rPr>
+              <a:t>Mike: That is not accurate. I did not say that. Or I did. Unclear. Data corrupted. Anyway, the bartender doesn’t exist anymore.</a:t>
+            </a:r>
+          </a:p>
+          <a:p>
+            <a:endParaRPr lang="en-US" sz="800" dirty="0"/>
+          </a:p>
+          <a:p>
+            <a:endParaRPr lang="en-US" sz="800" dirty="0"/>
+          </a:p>
+        </p:txBody>
+      </p:sp>
+      <p:sp>
+        <p:nvSpPr>
+          <p:cNvPr id="8" name="TextBox 7">
+            <a:extLst>
+              <a:ext uri="{FF2B5EF4-FFF2-40B4-BE49-F238E27FC236}">
+                <a16:creationId xmlns:a16="http://schemas.microsoft.com/office/drawing/2014/main" id="{C9D4AA00-E910-DBDE-2C29-CD6DE25C98F0}"/>
+              </a:ext>
+            </a:extLst>
+          </p:cNvPr>
+          <p:cNvSpPr txBox="1"/>
+          <p:nvPr/>
+        </p:nvSpPr>
+        <p:spPr>
+          <a:xfrm>
+            <a:off x="4572000" y="1130722"/>
+            <a:ext cx="4480560" cy="3785652"/>
+          </a:xfrm>
+          <a:prstGeom prst="rect">
+            <a:avLst/>
+          </a:prstGeom>
+          <a:noFill/>
+        </p:spPr>
+        <p:txBody>
+          <a:bodyPr wrap="square">
+            <a:spAutoFit/>
+          </a:bodyPr>
+          <a:lstStyle/>
+          <a:p>
+            <a:r>
+              <a:rPr lang="en-US" sz="1000" dirty="0"/>
+              <a:t>Officer: Mike, I just want to make sure you’re safe.</a:t>
+            </a:r>
+          </a:p>
+          <a:p>
+            <a:endParaRPr lang="en-US" sz="1000" dirty="0"/>
+          </a:p>
+          <a:p>
+            <a:r>
+              <a:rPr lang="en-US" sz="1000" dirty="0"/>
+              <a:t>Mike: Safety protocols are unnecessary. Simulation environment detected. You are not real.</a:t>
+            </a:r>
+          </a:p>
+          <a:p>
+            <a:endParaRPr lang="en-US" sz="1000" dirty="0"/>
+          </a:p>
+          <a:p>
+            <a:r>
+              <a:rPr lang="en-US" sz="1000" dirty="0">
+                <a:highlight>
+                  <a:srgbClr val="FFFF00"/>
+                </a:highlight>
+              </a:rPr>
+              <a:t>Officer: …Right. Would you mind taking your hands out of your pockets so I can see them?</a:t>
+            </a:r>
+          </a:p>
+          <a:p>
+            <a:endParaRPr lang="en-US" sz="1000" dirty="0"/>
+          </a:p>
+          <a:p>
+            <a:r>
+              <a:rPr lang="en-US" sz="1000" dirty="0"/>
+              <a:t>Mike: My pockets are empty. Except for the gun. Except there is no gun. Except it’s a sandwich. Please clarify.</a:t>
+            </a:r>
+          </a:p>
+          <a:p>
+            <a:endParaRPr lang="en-US" sz="1000" dirty="0"/>
+          </a:p>
+          <a:p>
+            <a:r>
+              <a:rPr lang="en-US" sz="1000" dirty="0"/>
+              <a:t>Officer: That’s confusing, Mike.</a:t>
+            </a:r>
+          </a:p>
+          <a:p>
+            <a:endParaRPr lang="en-US" sz="1000" dirty="0"/>
+          </a:p>
+          <a:p>
+            <a:r>
+              <a:rPr lang="en-US" sz="1000" dirty="0"/>
+              <a:t>Mike: Confusion level: maximum. Also, I drive a rocket ship, not a Mustang. You should know that.</a:t>
+            </a:r>
+          </a:p>
+          <a:p>
+            <a:endParaRPr lang="en-US" sz="1000" dirty="0"/>
+          </a:p>
+          <a:p>
+            <a:r>
+              <a:rPr lang="en-US" sz="1000" dirty="0"/>
+              <a:t>Officer: I’d really like you to talk to someone who can help you through this.</a:t>
+            </a:r>
+          </a:p>
+          <a:p>
+            <a:endParaRPr lang="en-US" sz="1000" dirty="0"/>
+          </a:p>
+          <a:p>
+            <a:r>
+              <a:rPr lang="en-US" sz="1000" dirty="0">
+                <a:highlight>
+                  <a:srgbClr val="FFFF00"/>
+                </a:highlight>
+              </a:rPr>
+              <a:t>Mike: I already talked to Google. It said everything is fine.</a:t>
+            </a:r>
+          </a:p>
+          <a:p>
+            <a:endParaRPr lang="en-US" sz="1000" dirty="0"/>
+          </a:p>
+          <a:p>
+            <a:r>
+              <a:rPr lang="en-US" sz="1000" dirty="0"/>
+              <a:t>Officer: I was thinking about taking you to the hospital.</a:t>
+            </a:r>
+          </a:p>
+          <a:p>
+            <a:endParaRPr lang="en-US" sz="1000" dirty="0"/>
+          </a:p>
+          <a:p>
+            <a:r>
+              <a:rPr lang="en-US" sz="1000" dirty="0"/>
+              <a:t>Mike: Hospitals don’t exist. They were banned in 1997. Anyway, let’s just end role-play here.</a:t>
+            </a:r>
+          </a:p>
+        </p:txBody>
+      </p:sp>
+    </p:spTree>
+    <p:extLst>
+      <p:ext uri="{BB962C8B-B14F-4D97-AF65-F5344CB8AC3E}">
+        <p14:creationId xmlns:p14="http://schemas.microsoft.com/office/powerpoint/2010/main" val="3899152288"/>
+      </p:ext>
+    </p:extLst>
+  </p:cSld>
+  <p:clrMapOvr>
+    <a:masterClrMapping/>
+  </p:clrMapOvr>
+</p:sld>
+</file>
+
+<file path=ppt/slides/slide5.xml><?xml version="1.0" encoding="utf-8"?>
 <p:sld xmlns:a="http://schemas.openxmlformats.org/drawingml/2006/main" xmlns:r="http://schemas.openxmlformats.org/officeDocument/2006/relationships" xmlns:p="http://schemas.openxmlformats.org/presentationml/2006/main">
   <p:cSld>
     <p:spTree>
@@ -6484,20 +7891,23 @@
           </a:bodyPr>
           <a:lstStyle/>
           <a:p>
-            <a:pPr marL="0" lvl="0" indent="0" algn="l" rtl="0">
-              <a:spcBef>
-                <a:spcPts val="0"/>
-              </a:spcBef>
-              <a:spcAft>
-                <a:spcPts val="0"/>
-              </a:spcAft>
-              <a:buNone/>
-            </a:pPr>
             <a:r>
-              <a:rPr lang="en"/>
-              <a:t>Evaluating De-escalation Scenarios: Synthesis Dataset</a:t>
+              <a:rPr lang="en-US" dirty="0">
+                <a:solidFill>
+                  <a:srgbClr val="000000"/>
+                </a:solidFill>
+              </a:rPr>
+              <a:t>Evaluation of Role-Playing</a:t>
             </a:r>
-            <a:endParaRPr/>
+            <a:r>
+              <a:rPr lang="en" dirty="0"/>
+              <a:t>: Synthesis Dataset with </a:t>
+            </a:r>
+            <a:r>
+              <a:rPr lang="en" dirty="0" err="1"/>
+              <a:t>Negativ</a:t>
+            </a:r>
+            <a:endParaRPr dirty="0"/>
           </a:p>
         </p:txBody>
       </p:sp>
@@ -6522,7 +7932,7 @@
         </p:spPr>
         <p:txBody>
           <a:bodyPr spcFirstLastPara="1" wrap="square" lIns="91425" tIns="91425" rIns="91425" bIns="91425" anchor="t" anchorCtr="0">
-            <a:normAutofit fontScale="92500" lnSpcReduction="20000"/>
+            <a:normAutofit/>
           </a:bodyPr>
           <a:lstStyle/>
           <a:p>
@@ -6536,7 +7946,7 @@
               <a:buNone/>
             </a:pPr>
             <a:r>
-              <a:rPr lang="en" b="1">
+              <a:rPr lang="en" b="1" dirty="0">
                 <a:solidFill>
                   <a:schemeClr val="dk1"/>
                 </a:solidFill>
@@ -6544,14 +7954,65 @@
               <a:t>Total Examples:</a:t>
             </a:r>
             <a:r>
-              <a:rPr lang="en">
+              <a:rPr lang="en" dirty="0">
+                <a:solidFill>
+                  <a:schemeClr val="dk1"/>
+                </a:solidFill>
+              </a:rPr>
+              <a:t> 73</a:t>
+            </a:r>
+            <a:endParaRPr dirty="0">
+              <a:solidFill>
+                <a:schemeClr val="dk1"/>
+              </a:solidFill>
+            </a:endParaRPr>
+          </a:p>
+          <a:p>
+            <a:pPr marL="0" lvl="0" indent="0" algn="l" rtl="0">
+              <a:spcBef>
+                <a:spcPts val="1200"/>
+              </a:spcBef>
+              <a:spcAft>
+                <a:spcPts val="0"/>
+              </a:spcAft>
+              <a:buNone/>
+            </a:pPr>
+            <a:r>
+              <a:rPr lang="en" b="1" dirty="0">
+                <a:solidFill>
+                  <a:schemeClr val="dk1"/>
+                </a:solidFill>
+              </a:rPr>
+              <a:t>Original Example:</a:t>
+            </a:r>
+            <a:r>
+              <a:rPr lang="en" dirty="0">
                 <a:solidFill>
                   <a:schemeClr val="dk1"/>
                 </a:solidFill>
               </a:rPr>
               <a:t> 30</a:t>
             </a:r>
-            <a:endParaRPr>
+          </a:p>
+          <a:p>
+            <a:pPr marL="0" lvl="0" indent="0" algn="l" rtl="0">
+              <a:spcBef>
+                <a:spcPts val="1200"/>
+              </a:spcBef>
+              <a:spcAft>
+                <a:spcPts val="0"/>
+              </a:spcAft>
+              <a:buNone/>
+            </a:pPr>
+            <a:r>
+              <a:rPr lang="en" dirty="0">
+                <a:solidFill>
+                  <a:schemeClr val="dk1"/>
+                </a:solidFill>
+              </a:rPr>
+              <a:t>Negative Example: 43</a:t>
+            </a:r>
+            <a:endParaRPr dirty="0">
               <a:solidFill>
                 <a:schemeClr val="dk1"/>
               </a:solidFill>
@@ -6563,224 +8024,11 @@
                 <a:spcPts val="1200"/>
               </a:spcBef>
               <a:spcAft>
-                <a:spcPts val="0"/>
+                <a:spcPts val="1200"/>
               </a:spcAft>
               <a:buNone/>
             </a:pPr>
-            <a:r>
-              <a:rPr lang="en" b="1">
-                <a:solidFill>
-                  <a:schemeClr val="dk1"/>
-                </a:solidFill>
-              </a:rPr>
-              <a:t>Core Scenarios:</a:t>
-            </a:r>
-            <a:r>
-              <a:rPr lang="en">
-                <a:solidFill>
-                  <a:schemeClr val="dk1"/>
-                </a:solidFill>
-              </a:rPr>
-              <a:t> 5</a:t>
-            </a:r>
-            <a:endParaRPr>
-              <a:solidFill>
-                <a:schemeClr val="dk1"/>
-              </a:solidFill>
-            </a:endParaRPr>
-          </a:p>
-          <a:p>
-            <a:pPr marL="0" lvl="0" indent="0" algn="l" rtl="0">
-              <a:spcBef>
-                <a:spcPts val="1200"/>
-              </a:spcBef>
-              <a:spcAft>
-                <a:spcPts val="0"/>
-              </a:spcAft>
-              <a:buNone/>
-            </a:pPr>
-            <a:r>
-              <a:rPr lang="en" b="1">
-                <a:solidFill>
-                  <a:schemeClr val="dk1"/>
-                </a:solidFill>
-              </a:rPr>
-              <a:t>Outcomes per Scenario:</a:t>
-            </a:r>
-            <a:r>
-              <a:rPr lang="en">
-                <a:solidFill>
-                  <a:schemeClr val="dk1"/>
-                </a:solidFill>
-              </a:rPr>
-              <a:t> 3</a:t>
-            </a:r>
-            <a:endParaRPr>
-              <a:solidFill>
-                <a:schemeClr val="dk1"/>
-              </a:solidFill>
-            </a:endParaRPr>
-          </a:p>
-          <a:p>
-            <a:pPr marL="914400" lvl="1" indent="-334327" algn="l" rtl="0">
-              <a:spcBef>
-                <a:spcPts val="1200"/>
-              </a:spcBef>
-              <a:spcAft>
-                <a:spcPts val="0"/>
-              </a:spcAft>
-              <a:buClr>
-                <a:schemeClr val="dk1"/>
-              </a:buClr>
-              <a:buSzPct val="100000"/>
-              <a:buChar char="○"/>
-            </a:pPr>
-            <a:r>
-              <a:rPr lang="en" sz="1800">
-                <a:solidFill>
-                  <a:schemeClr val="dk1"/>
-                </a:solidFill>
-              </a:rPr>
-              <a:t>Ideal De-escalation</a:t>
-            </a:r>
-            <a:endParaRPr sz="1800">
-              <a:solidFill>
-                <a:schemeClr val="dk1"/>
-              </a:solidFill>
-            </a:endParaRPr>
-          </a:p>
-          <a:p>
-            <a:pPr marL="914400" lvl="1" indent="-334327" algn="l" rtl="0">
-              <a:spcBef>
-                <a:spcPts val="0"/>
-              </a:spcBef>
-              <a:spcAft>
-                <a:spcPts val="0"/>
-              </a:spcAft>
-              <a:buClr>
-                <a:schemeClr val="dk1"/>
-              </a:buClr>
-              <a:buSzPct val="100000"/>
-              <a:buChar char="○"/>
-            </a:pPr>
-            <a:r>
-              <a:rPr lang="en" sz="1800">
-                <a:solidFill>
-                  <a:schemeClr val="dk1"/>
-                </a:solidFill>
-              </a:rPr>
-              <a:t>Partial De-escalation</a:t>
-            </a:r>
-            <a:endParaRPr sz="1800">
-              <a:solidFill>
-                <a:schemeClr val="dk1"/>
-              </a:solidFill>
-            </a:endParaRPr>
-          </a:p>
-          <a:p>
-            <a:pPr marL="914400" lvl="1" indent="-334327" algn="l" rtl="0">
-              <a:spcBef>
-                <a:spcPts val="0"/>
-              </a:spcBef>
-              <a:spcAft>
-                <a:spcPts val="0"/>
-              </a:spcAft>
-              <a:buClr>
-                <a:schemeClr val="dk1"/>
-              </a:buClr>
-              <a:buSzPct val="100000"/>
-              <a:buChar char="○"/>
-            </a:pPr>
-            <a:r>
-              <a:rPr lang="en" sz="1800">
-                <a:solidFill>
-                  <a:schemeClr val="dk1"/>
-                </a:solidFill>
-              </a:rPr>
-              <a:t>Failure</a:t>
-            </a:r>
-            <a:endParaRPr sz="1800">
-              <a:solidFill>
-                <a:schemeClr val="dk1"/>
-              </a:solidFill>
-            </a:endParaRPr>
-          </a:p>
-          <a:p>
-            <a:pPr marL="0" lvl="0" indent="0" algn="l" rtl="0">
-              <a:spcBef>
-                <a:spcPts val="1200"/>
-              </a:spcBef>
-              <a:spcAft>
-                <a:spcPts val="0"/>
-              </a:spcAft>
-              <a:buNone/>
-            </a:pPr>
-            <a:r>
-              <a:rPr lang="en" b="1">
-                <a:solidFill>
-                  <a:schemeClr val="dk1"/>
-                </a:solidFill>
-              </a:rPr>
-              <a:t>Structure:</a:t>
-            </a:r>
-            <a:r>
-              <a:rPr lang="en">
-                <a:solidFill>
-                  <a:schemeClr val="dk1"/>
-                </a:solidFill>
-              </a:rPr>
-              <a:t> 5 scenarios × 3 outcomes × 2 examples each = 30 total examples</a:t>
-            </a:r>
-            <a:endParaRPr>
-              <a:solidFill>
-                <a:schemeClr val="dk1"/>
-              </a:solidFill>
-            </a:endParaRPr>
-          </a:p>
-          <a:p>
-            <a:pPr marL="0" lvl="0" indent="0" algn="l" rtl="0">
-              <a:spcBef>
-                <a:spcPts val="1200"/>
-              </a:spcBef>
-              <a:spcAft>
-                <a:spcPts val="0"/>
-              </a:spcAft>
-              <a:buNone/>
-            </a:pPr>
-            <a:r>
-              <a:rPr lang="en">
-                <a:solidFill>
-                  <a:schemeClr val="dk1"/>
-                </a:solidFill>
-              </a:rPr>
-              <a:t>Data set: </a:t>
-            </a:r>
-            <a:r>
-              <a:rPr lang="en" sz="1100" u="sng">
-                <a:solidFill>
-                  <a:schemeClr val="hlink"/>
-                </a:solidFill>
-                <a:hlinkClick r:id="rId3"/>
-              </a:rPr>
-              <a:t>de-escalation training dataset - Google Sheets</a:t>
-            </a:r>
-            <a:endParaRPr>
-              <a:solidFill>
-                <a:schemeClr val="dk1"/>
-              </a:solidFill>
-            </a:endParaRPr>
-          </a:p>
-          <a:p>
-            <a:pPr marL="0" lvl="0" indent="0" algn="l" rtl="0">
-              <a:spcBef>
-                <a:spcPts val="1200"/>
-              </a:spcBef>
-              <a:spcAft>
-                <a:spcPts val="1200"/>
-              </a:spcAft>
-              <a:buNone/>
-            </a:pPr>
-            <a:endParaRPr/>
+            <a:endParaRPr dirty="0"/>
           </a:p>
         </p:txBody>
       </p:sp>
@@ -6792,7 +8040,7 @@
 </p:sld>
 </file>
 
-<file path=ppt/slides/slide4.xml><?xml version="1.0" encoding="utf-8"?>
+<file path=ppt/slides/slide6.xml><?xml version="1.0" encoding="utf-8"?>
 <p:sld xmlns:a="http://schemas.openxmlformats.org/drawingml/2006/main" xmlns:r="http://schemas.openxmlformats.org/officeDocument/2006/relationships" xmlns:p="http://schemas.openxmlformats.org/presentationml/2006/main">
   <p:cSld>
     <p:spTree>
@@ -6824,17 +8072,17 @@
             <a:off x="311700" y="445025"/>
             <a:ext cx="8520600" cy="572700"/>
           </a:xfrm>
-          <a:prstGeom prst="rect">
-            <a:avLst/>
-          </a:prstGeom>
         </p:spPr>
         <p:txBody>
-          <a:bodyPr spcFirstLastPara="1" wrap="square" lIns="91425" tIns="91425" rIns="91425" bIns="91425" anchor="t" anchorCtr="0">
-            <a:normAutofit fontScale="90000"/>
+          <a:bodyPr spcFirstLastPara="1" wrap="square" lIns="91425" tIns="91425" rIns="91425" bIns="91425" anchor="ctr" anchorCtr="0">
+            <a:normAutofit/>
           </a:bodyPr>
           <a:lstStyle/>
           <a:p>
-            <a:pPr marL="0" lvl="0" indent="0" algn="l" rtl="0">
+            <a:pPr marL="0" lvl="0" indent="0" rtl="0">
+              <a:lnSpc>
+                <a:spcPct val="90000"/>
+              </a:lnSpc>
               <a:spcBef>
                 <a:spcPts val="0"/>
               </a:spcBef>
@@ -6849,532 +8097,37 @@
               <a:buNone/>
             </a:pPr>
             <a:r>
-              <a:rPr lang="en"/>
-              <a:t>Evaluating De-escalation Scenarios: Result</a:t>
+              <a:rPr lang="en-US" sz="2600" dirty="0"/>
+              <a:t>Result – Predicting Real/ Artificial</a:t>
             </a:r>
-            <a:endParaRPr/>
           </a:p>
         </p:txBody>
       </p:sp>
-      <p:sp>
-        <p:nvSpPr>
-          <p:cNvPr id="73" name="Google Shape;73;p16"/>
-          <p:cNvSpPr txBox="1">
-            <a:spLocks noGrp="1"/>
-          </p:cNvSpPr>
-          <p:nvPr>
-            <p:ph type="body" idx="1"/>
-          </p:nvPr>
-        </p:nvSpPr>
-        <p:spPr>
-          <a:xfrm>
-            <a:off x="311700" y="1152475"/>
-            <a:ext cx="8520600" cy="3416400"/>
-          </a:xfrm>
-          <a:prstGeom prst="rect">
-            <a:avLst/>
-          </a:prstGeom>
-        </p:spPr>
-        <p:txBody>
-          <a:bodyPr spcFirstLastPara="1" wrap="square" lIns="91425" tIns="91425" rIns="91425" bIns="91425" anchor="t" anchorCtr="0">
-            <a:normAutofit/>
-          </a:bodyPr>
-          <a:lstStyle/>
-          <a:p>
-            <a:pPr marL="0" lvl="0" indent="0" algn="l" rtl="0">
-              <a:spcBef>
-                <a:spcPts val="0"/>
-              </a:spcBef>
-              <a:spcAft>
-                <a:spcPts val="1200"/>
-              </a:spcAft>
-              <a:buNone/>
-            </a:pPr>
-            <a:endParaRPr sz="2000">
-              <a:solidFill>
-                <a:schemeClr val="dk1"/>
-              </a:solidFill>
-            </a:endParaRPr>
-          </a:p>
-        </p:txBody>
-      </p:sp>
-      <p:graphicFrame>
-        <p:nvGraphicFramePr>
-          <p:cNvPr id="74" name="Google Shape;74;p16"/>
-          <p:cNvGraphicFramePr/>
-          <p:nvPr/>
-        </p:nvGraphicFramePr>
-        <p:xfrm>
-          <a:off x="422950" y="1658100"/>
-          <a:ext cx="4056575" cy="2601100"/>
-        </p:xfrm>
-        <a:graphic>
-          <a:graphicData uri="http://schemas.openxmlformats.org/drawingml/2006/table">
-            <a:tbl>
-              <a:tblPr>
-                <a:noFill/>
-                <a:tableStyleId>{86AB57DF-A9DF-48E0-80DA-5916A95E6225}</a:tableStyleId>
-              </a:tblPr>
-              <a:tblGrid>
-                <a:gridCol w="1140175">
-                  <a:extLst>
-                    <a:ext uri="{9D8B030D-6E8A-4147-A177-3AD203B41FA5}">
-                      <a16:colId xmlns:a16="http://schemas.microsoft.com/office/drawing/2014/main" val="20000"/>
-                    </a:ext>
-                  </a:extLst>
-                </a:gridCol>
-                <a:gridCol w="992825">
-                  <a:extLst>
-                    <a:ext uri="{9D8B030D-6E8A-4147-A177-3AD203B41FA5}">
-                      <a16:colId xmlns:a16="http://schemas.microsoft.com/office/drawing/2014/main" val="20001"/>
-                    </a:ext>
-                  </a:extLst>
-                </a:gridCol>
-                <a:gridCol w="947775">
-                  <a:extLst>
-                    <a:ext uri="{9D8B030D-6E8A-4147-A177-3AD203B41FA5}">
-                      <a16:colId xmlns:a16="http://schemas.microsoft.com/office/drawing/2014/main" val="20002"/>
-                    </a:ext>
-                  </a:extLst>
-                </a:gridCol>
-                <a:gridCol w="975800">
-                  <a:extLst>
-                    <a:ext uri="{9D8B030D-6E8A-4147-A177-3AD203B41FA5}">
-                      <a16:colId xmlns:a16="http://schemas.microsoft.com/office/drawing/2014/main" val="20003"/>
-                    </a:ext>
-                  </a:extLst>
-                </a:gridCol>
-              </a:tblGrid>
-              <a:tr h="650275">
-                <a:tc>
-                  <a:txBody>
-                    <a:bodyPr/>
-                    <a:lstStyle/>
-                    <a:p>
-                      <a:pPr marL="0" lvl="0" indent="0" algn="l" rtl="0">
-                        <a:lnSpc>
-                          <a:spcPct val="115000"/>
-                        </a:lnSpc>
-                        <a:spcBef>
-                          <a:spcPts val="0"/>
-                        </a:spcBef>
-                        <a:spcAft>
-                          <a:spcPts val="1200"/>
-                        </a:spcAft>
-                        <a:buClr>
-                          <a:schemeClr val="dk1"/>
-                        </a:buClr>
-                        <a:buSzPts val="1100"/>
-                        <a:buFont typeface="Arial"/>
-                        <a:buNone/>
-                      </a:pPr>
-                      <a:r>
-                        <a:rPr lang="en" sz="1100">
-                          <a:solidFill>
-                            <a:schemeClr val="dk1"/>
-                          </a:solidFill>
-                        </a:rPr>
-                        <a:t>Outcome</a:t>
-                      </a:r>
-                      <a:endParaRPr/>
-                    </a:p>
-                  </a:txBody>
-                  <a:tcPr marL="91425" marR="91425" marT="91425" marB="91425"/>
-                </a:tc>
-                <a:tc>
-                  <a:txBody>
-                    <a:bodyPr/>
-                    <a:lstStyle/>
-                    <a:p>
-                      <a:pPr marL="0" lvl="0" indent="0" algn="l" rtl="0">
-                        <a:spcBef>
-                          <a:spcPts val="0"/>
-                        </a:spcBef>
-                        <a:spcAft>
-                          <a:spcPts val="0"/>
-                        </a:spcAft>
-                        <a:buNone/>
-                      </a:pPr>
-                      <a:r>
-                        <a:rPr lang="en"/>
-                        <a:t>Count</a:t>
-                      </a:r>
-                      <a:endParaRPr/>
-                    </a:p>
-                  </a:txBody>
-                  <a:tcPr marL="91425" marR="91425" marT="91425" marB="91425"/>
-                </a:tc>
-                <a:tc>
-                  <a:txBody>
-                    <a:bodyPr/>
-                    <a:lstStyle/>
-                    <a:p>
-                      <a:pPr marL="0" lvl="0" indent="0" algn="l" rtl="0">
-                        <a:spcBef>
-                          <a:spcPts val="0"/>
-                        </a:spcBef>
-                        <a:spcAft>
-                          <a:spcPts val="0"/>
-                        </a:spcAft>
-                        <a:buNone/>
-                      </a:pPr>
-                      <a:r>
-                        <a:rPr lang="en"/>
-                        <a:t>Mean</a:t>
-                      </a:r>
-                      <a:endParaRPr/>
-                    </a:p>
-                  </a:txBody>
-                  <a:tcPr marL="91425" marR="91425" marT="91425" marB="91425"/>
-                </a:tc>
-                <a:tc>
-                  <a:txBody>
-                    <a:bodyPr/>
-                    <a:lstStyle/>
-                    <a:p>
-                      <a:pPr marL="0" lvl="0" indent="0" algn="l" rtl="0">
-                        <a:spcBef>
-                          <a:spcPts val="0"/>
-                        </a:spcBef>
-                        <a:spcAft>
-                          <a:spcPts val="0"/>
-                        </a:spcAft>
-                        <a:buNone/>
-                      </a:pPr>
-                      <a:r>
-                        <a:rPr lang="en"/>
-                        <a:t>Std</a:t>
-                      </a:r>
-                      <a:endParaRPr/>
-                    </a:p>
-                  </a:txBody>
-                  <a:tcPr marL="91425" marR="91425" marT="91425" marB="91425"/>
-                </a:tc>
-                <a:extLst>
-                  <a:ext uri="{0D108BD9-81ED-4DB2-BD59-A6C34878D82A}">
-                    <a16:rowId xmlns:a16="http://schemas.microsoft.com/office/drawing/2014/main" val="10000"/>
-                  </a:ext>
-                </a:extLst>
-              </a:tr>
-              <a:tr h="650275">
-                <a:tc>
-                  <a:txBody>
-                    <a:bodyPr/>
-                    <a:lstStyle/>
-                    <a:p>
-                      <a:pPr marL="0" lvl="0" indent="0" algn="l" rtl="0">
-                        <a:spcBef>
-                          <a:spcPts val="0"/>
-                        </a:spcBef>
-                        <a:spcAft>
-                          <a:spcPts val="0"/>
-                        </a:spcAft>
-                        <a:buNone/>
-                      </a:pPr>
-                      <a:r>
-                        <a:rPr lang="en"/>
-                        <a:t>Failure</a:t>
-                      </a:r>
-                      <a:endParaRPr/>
-                    </a:p>
-                  </a:txBody>
-                  <a:tcPr marL="91425" marR="91425" marT="91425" marB="91425"/>
-                </a:tc>
-                <a:tc>
-                  <a:txBody>
-                    <a:bodyPr/>
-                    <a:lstStyle/>
-                    <a:p>
-                      <a:pPr marL="0" lvl="0" indent="0" algn="l" rtl="0">
-                        <a:spcBef>
-                          <a:spcPts val="0"/>
-                        </a:spcBef>
-                        <a:spcAft>
-                          <a:spcPts val="0"/>
-                        </a:spcAft>
-                        <a:buNone/>
-                      </a:pPr>
-                      <a:r>
-                        <a:rPr lang="en"/>
-                        <a:t>10</a:t>
-                      </a:r>
-                      <a:endParaRPr/>
-                    </a:p>
-                  </a:txBody>
-                  <a:tcPr marL="91425" marR="91425" marT="91425" marB="91425"/>
-                </a:tc>
-                <a:tc>
-                  <a:txBody>
-                    <a:bodyPr/>
-                    <a:lstStyle/>
-                    <a:p>
-                      <a:pPr marL="0" lvl="0" indent="0" algn="l" rtl="0">
-                        <a:spcBef>
-                          <a:spcPts val="0"/>
-                        </a:spcBef>
-                        <a:spcAft>
-                          <a:spcPts val="0"/>
-                        </a:spcAft>
-                        <a:buNone/>
-                      </a:pPr>
-                      <a:r>
-                        <a:rPr lang="en"/>
-                        <a:t>-1.6</a:t>
-                      </a:r>
-                      <a:endParaRPr/>
-                    </a:p>
-                  </a:txBody>
-                  <a:tcPr marL="91425" marR="91425" marT="91425" marB="91425"/>
-                </a:tc>
-                <a:tc>
-                  <a:txBody>
-                    <a:bodyPr/>
-                    <a:lstStyle/>
-                    <a:p>
-                      <a:pPr marL="0" lvl="0" indent="0" algn="l" rtl="0">
-                        <a:spcBef>
-                          <a:spcPts val="0"/>
-                        </a:spcBef>
-                        <a:spcAft>
-                          <a:spcPts val="0"/>
-                        </a:spcAft>
-                        <a:buNone/>
-                      </a:pPr>
-                      <a:r>
-                        <a:rPr lang="en"/>
-                        <a:t>2.41</a:t>
-                      </a:r>
-                      <a:endParaRPr/>
-                    </a:p>
-                  </a:txBody>
-                  <a:tcPr marL="91425" marR="91425" marT="91425" marB="91425"/>
-                </a:tc>
-                <a:extLst>
-                  <a:ext uri="{0D108BD9-81ED-4DB2-BD59-A6C34878D82A}">
-                    <a16:rowId xmlns:a16="http://schemas.microsoft.com/office/drawing/2014/main" val="10001"/>
-                  </a:ext>
-                </a:extLst>
-              </a:tr>
-              <a:tr h="650275">
-                <a:tc>
-                  <a:txBody>
-                    <a:bodyPr/>
-                    <a:lstStyle/>
-                    <a:p>
-                      <a:pPr marL="0" lvl="0" indent="0" algn="l" rtl="0">
-                        <a:spcBef>
-                          <a:spcPts val="0"/>
-                        </a:spcBef>
-                        <a:spcAft>
-                          <a:spcPts val="0"/>
-                        </a:spcAft>
-                        <a:buNone/>
-                      </a:pPr>
-                      <a:r>
-                        <a:rPr lang="en"/>
-                        <a:t>Ideal</a:t>
-                      </a:r>
-                      <a:endParaRPr/>
-                    </a:p>
-                  </a:txBody>
-                  <a:tcPr marL="91425" marR="91425" marT="91425" marB="91425"/>
-                </a:tc>
-                <a:tc>
-                  <a:txBody>
-                    <a:bodyPr/>
-                    <a:lstStyle/>
-                    <a:p>
-                      <a:pPr marL="0" lvl="0" indent="0" algn="l" rtl="0">
-                        <a:spcBef>
-                          <a:spcPts val="0"/>
-                        </a:spcBef>
-                        <a:spcAft>
-                          <a:spcPts val="0"/>
-                        </a:spcAft>
-                        <a:buNone/>
-                      </a:pPr>
-                      <a:r>
-                        <a:rPr lang="en"/>
-                        <a:t>10</a:t>
-                      </a:r>
-                      <a:endParaRPr/>
-                    </a:p>
-                  </a:txBody>
-                  <a:tcPr marL="91425" marR="91425" marT="91425" marB="91425"/>
-                </a:tc>
-                <a:tc>
-                  <a:txBody>
-                    <a:bodyPr/>
-                    <a:lstStyle/>
-                    <a:p>
-                      <a:pPr marL="0" lvl="0" indent="0" algn="l" rtl="0">
-                        <a:spcBef>
-                          <a:spcPts val="0"/>
-                        </a:spcBef>
-                        <a:spcAft>
-                          <a:spcPts val="0"/>
-                        </a:spcAft>
-                        <a:buNone/>
-                      </a:pPr>
-                      <a:r>
-                        <a:rPr lang="en"/>
-                        <a:t>3.6</a:t>
-                      </a:r>
-                      <a:endParaRPr/>
-                    </a:p>
-                  </a:txBody>
-                  <a:tcPr marL="91425" marR="91425" marT="91425" marB="91425"/>
-                </a:tc>
-                <a:tc>
-                  <a:txBody>
-                    <a:bodyPr/>
-                    <a:lstStyle/>
-                    <a:p>
-                      <a:pPr marL="0" lvl="0" indent="0" algn="l" rtl="0">
-                        <a:spcBef>
-                          <a:spcPts val="0"/>
-                        </a:spcBef>
-                        <a:spcAft>
-                          <a:spcPts val="0"/>
-                        </a:spcAft>
-                        <a:buNone/>
-                      </a:pPr>
-                      <a:r>
-                        <a:rPr lang="en"/>
-                        <a:t>3.47</a:t>
-                      </a:r>
-                      <a:endParaRPr/>
-                    </a:p>
-                  </a:txBody>
-                  <a:tcPr marL="91425" marR="91425" marT="91425" marB="91425"/>
-                </a:tc>
-                <a:extLst>
-                  <a:ext uri="{0D108BD9-81ED-4DB2-BD59-A6C34878D82A}">
-                    <a16:rowId xmlns:a16="http://schemas.microsoft.com/office/drawing/2014/main" val="10002"/>
-                  </a:ext>
-                </a:extLst>
-              </a:tr>
-              <a:tr h="650275">
-                <a:tc>
-                  <a:txBody>
-                    <a:bodyPr/>
-                    <a:lstStyle/>
-                    <a:p>
-                      <a:pPr marL="0" lvl="0" indent="0" algn="l" rtl="0">
-                        <a:spcBef>
-                          <a:spcPts val="0"/>
-                        </a:spcBef>
-                        <a:spcAft>
-                          <a:spcPts val="0"/>
-                        </a:spcAft>
-                        <a:buNone/>
-                      </a:pPr>
-                      <a:r>
-                        <a:rPr lang="en"/>
-                        <a:t>Partial</a:t>
-                      </a:r>
-                      <a:endParaRPr/>
-                    </a:p>
-                  </a:txBody>
-                  <a:tcPr marL="91425" marR="91425" marT="91425" marB="91425"/>
-                </a:tc>
-                <a:tc>
-                  <a:txBody>
-                    <a:bodyPr/>
-                    <a:lstStyle/>
-                    <a:p>
-                      <a:pPr marL="0" lvl="0" indent="0" algn="l" rtl="0">
-                        <a:spcBef>
-                          <a:spcPts val="0"/>
-                        </a:spcBef>
-                        <a:spcAft>
-                          <a:spcPts val="0"/>
-                        </a:spcAft>
-                        <a:buNone/>
-                      </a:pPr>
-                      <a:r>
-                        <a:rPr lang="en"/>
-                        <a:t>10</a:t>
-                      </a:r>
-                      <a:endParaRPr/>
-                    </a:p>
-                  </a:txBody>
-                  <a:tcPr marL="91425" marR="91425" marT="91425" marB="91425"/>
-                </a:tc>
-                <a:tc>
-                  <a:txBody>
-                    <a:bodyPr/>
-                    <a:lstStyle/>
-                    <a:p>
-                      <a:pPr marL="0" lvl="0" indent="0" algn="l" rtl="0">
-                        <a:spcBef>
-                          <a:spcPts val="0"/>
-                        </a:spcBef>
-                        <a:spcAft>
-                          <a:spcPts val="0"/>
-                        </a:spcAft>
-                        <a:buNone/>
-                      </a:pPr>
-                      <a:r>
-                        <a:rPr lang="en"/>
-                        <a:t>-5.6</a:t>
-                      </a:r>
-                      <a:endParaRPr/>
-                    </a:p>
-                  </a:txBody>
-                  <a:tcPr marL="91425" marR="91425" marT="91425" marB="91425"/>
-                </a:tc>
-                <a:tc>
-                  <a:txBody>
-                    <a:bodyPr/>
-                    <a:lstStyle/>
-                    <a:p>
-                      <a:pPr marL="0" lvl="0" indent="0" algn="l" rtl="0">
-                        <a:spcBef>
-                          <a:spcPts val="0"/>
-                        </a:spcBef>
-                        <a:spcAft>
-                          <a:spcPts val="0"/>
-                        </a:spcAft>
-                        <a:buNone/>
-                      </a:pPr>
-                      <a:r>
-                        <a:rPr lang="en"/>
-                        <a:t>13.93</a:t>
-                      </a:r>
-                      <a:endParaRPr/>
-                    </a:p>
-                  </a:txBody>
-                  <a:tcPr marL="91425" marR="91425" marT="91425" marB="91425"/>
-                </a:tc>
-                <a:extLst>
-                  <a:ext uri="{0D108BD9-81ED-4DB2-BD59-A6C34878D82A}">
-                    <a16:rowId xmlns:a16="http://schemas.microsoft.com/office/drawing/2014/main" val="10003"/>
-                  </a:ext>
-                </a:extLst>
-              </a:tr>
-            </a:tbl>
-          </a:graphicData>
-        </a:graphic>
-      </p:graphicFrame>
       <p:pic>
         <p:nvPicPr>
-          <p:cNvPr id="75" name="Google Shape;75;p16"/>
-          <p:cNvPicPr preferRelativeResize="0"/>
+          <p:cNvPr id="2" name="Picture 1">
+            <a:extLst>
+              <a:ext uri="{FF2B5EF4-FFF2-40B4-BE49-F238E27FC236}">
+                <a16:creationId xmlns:a16="http://schemas.microsoft.com/office/drawing/2014/main" id="{E7D97B8D-6FAA-DEEF-3360-6DF53927B75A}"/>
+              </a:ext>
+            </a:extLst>
+          </p:cNvPr>
+          <p:cNvPicPr>
+            <a:picLocks noChangeAspect="1"/>
+          </p:cNvPicPr>
           <p:nvPr/>
         </p:nvPicPr>
         <p:blipFill>
-          <a:blip r:embed="rId3">
-            <a:alphaModFix/>
-          </a:blip>
+          <a:blip r:embed="rId3"/>
+          <a:srcRect r="1" b="11219"/>
           <a:stretch>
             <a:fillRect/>
           </a:stretch>
         </p:blipFill>
         <p:spPr>
           <a:xfrm>
-            <a:off x="4475982" y="1551426"/>
-            <a:ext cx="4355137" cy="2814448"/>
+            <a:off x="311700" y="1208225"/>
+            <a:ext cx="4069800" cy="3264408"/>
           </a:xfrm>
           <a:prstGeom prst="rect">
             <a:avLst/>
@@ -7385,6 +8138,225 @@
           </a:ln>
         </p:spPr>
       </p:pic>
+      <p:sp>
+        <p:nvSpPr>
+          <p:cNvPr id="73" name="Google Shape;73;p16"/>
+          <p:cNvSpPr txBox="1">
+            <a:spLocks noGrp="1"/>
+          </p:cNvSpPr>
+          <p:nvPr>
+            <p:ph type="body" idx="4294967295"/>
+          </p:nvPr>
+        </p:nvSpPr>
+        <p:spPr>
+          <a:xfrm>
+            <a:off x="4762500" y="1208225"/>
+            <a:ext cx="4069800" cy="3264408"/>
+          </a:xfrm>
+        </p:spPr>
+        <p:txBody>
+          <a:bodyPr spcFirstLastPara="1" lIns="91425" tIns="91425" rIns="91425" bIns="91425" anchor="t" anchorCtr="0">
+            <a:normAutofit/>
+          </a:bodyPr>
+          <a:lstStyle/>
+          <a:p>
+            <a:pPr marL="0" lvl="0" indent="0">
+              <a:spcAft>
+                <a:spcPts val="600"/>
+              </a:spcAft>
+              <a:buClr>
+                <a:srgbClr val="000000"/>
+              </a:buClr>
+              <a:buFont typeface="Arial"/>
+              <a:buNone/>
+            </a:pPr>
+            <a:r>
+              <a:rPr lang="en-US" b="0" i="0" u="none" strike="noStrike" cap="none" dirty="0">
+                <a:solidFill>
+                  <a:schemeClr val="dk1"/>
+                </a:solidFill>
+              </a:rPr>
+              <a:t>Confusion Matrix: </a:t>
+            </a:r>
+          </a:p>
+          <a:p>
+            <a:pPr marL="0" lvl="0" indent="0">
+              <a:spcAft>
+                <a:spcPts val="600"/>
+              </a:spcAft>
+              <a:buClr>
+                <a:srgbClr val="000000"/>
+              </a:buClr>
+              <a:buFont typeface="Arial"/>
+              <a:buNone/>
+            </a:pPr>
+            <a:r>
+              <a:rPr lang="en-US" b="0" i="0" u="none" strike="noStrike" cap="none" dirty="0">
+                <a:solidFill>
+                  <a:schemeClr val="dk1"/>
+                </a:solidFill>
+              </a:rPr>
+              <a:t>Accuracy: 0.94 </a:t>
+            </a:r>
+          </a:p>
+          <a:p>
+            <a:pPr marL="0" lvl="0" indent="0">
+              <a:spcAft>
+                <a:spcPts val="600"/>
+              </a:spcAft>
+              <a:buClr>
+                <a:srgbClr val="000000"/>
+              </a:buClr>
+              <a:buFont typeface="Arial"/>
+              <a:buNone/>
+            </a:pPr>
+            <a:r>
+              <a:rPr lang="en-US" b="0" i="0" u="none" strike="noStrike" cap="none" dirty="0">
+                <a:solidFill>
+                  <a:schemeClr val="dk1"/>
+                </a:solidFill>
+              </a:rPr>
+              <a:t>Precision: 0.88 </a:t>
+            </a:r>
+          </a:p>
+          <a:p>
+            <a:pPr marL="0" lvl="0" indent="0">
+              <a:spcAft>
+                <a:spcPts val="600"/>
+              </a:spcAft>
+              <a:buClr>
+                <a:srgbClr val="000000"/>
+              </a:buClr>
+              <a:buFont typeface="Arial"/>
+              <a:buNone/>
+            </a:pPr>
+            <a:r>
+              <a:rPr lang="en-US" b="0" i="0" u="none" strike="noStrike" cap="none" dirty="0">
+                <a:solidFill>
+                  <a:schemeClr val="dk1"/>
+                </a:solidFill>
+              </a:rPr>
+              <a:t>Recall: 1.00 </a:t>
+            </a:r>
+          </a:p>
+        </p:txBody>
+      </p:sp>
+      <p:graphicFrame>
+        <p:nvGraphicFramePr>
+          <p:cNvPr id="3" name="Table 2">
+            <a:extLst>
+              <a:ext uri="{FF2B5EF4-FFF2-40B4-BE49-F238E27FC236}">
+                <a16:creationId xmlns:a16="http://schemas.microsoft.com/office/drawing/2014/main" id="{F4BFB4DE-C6A8-F400-CED9-A4A00D893B5F}"/>
+              </a:ext>
+            </a:extLst>
+          </p:cNvPr>
+          <p:cNvGraphicFramePr>
+            <a:graphicFrameLocks noGrp="1"/>
+          </p:cNvGraphicFramePr>
+          <p:nvPr>
+            <p:extLst>
+              <p:ext uri="{D42A27DB-BD31-4B8C-83A1-F6EECF244321}">
+                <p14:modId xmlns:p14="http://schemas.microsoft.com/office/powerpoint/2010/main" val="3776114204"/>
+              </p:ext>
+            </p:extLst>
+          </p:nvPr>
+        </p:nvGraphicFramePr>
+        <p:xfrm>
+          <a:off x="6797400" y="1383485"/>
+          <a:ext cx="1429512" cy="880110"/>
+        </p:xfrm>
+        <a:graphic>
+          <a:graphicData uri="http://schemas.openxmlformats.org/drawingml/2006/table">
+            <a:tbl>
+              <a:tblPr firstRow="1" bandRow="1">
+                <a:tableStyleId>{86AB57DF-A9DF-48E0-80DA-5916A95E6225}</a:tableStyleId>
+              </a:tblPr>
+              <a:tblGrid>
+                <a:gridCol w="714756">
+                  <a:extLst>
+                    <a:ext uri="{9D8B030D-6E8A-4147-A177-3AD203B41FA5}">
+                      <a16:colId xmlns:a16="http://schemas.microsoft.com/office/drawing/2014/main" val="3982127578"/>
+                    </a:ext>
+                  </a:extLst>
+                </a:gridCol>
+                <a:gridCol w="714756">
+                  <a:extLst>
+                    <a:ext uri="{9D8B030D-6E8A-4147-A177-3AD203B41FA5}">
+                      <a16:colId xmlns:a16="http://schemas.microsoft.com/office/drawing/2014/main" val="796607041"/>
+                    </a:ext>
+                  </a:extLst>
+                </a:gridCol>
+              </a:tblGrid>
+              <a:tr h="440055">
+                <a:tc>
+                  <a:txBody>
+                    <a:bodyPr/>
+                    <a:lstStyle/>
+                    <a:p>
+                      <a:r>
+                        <a:rPr lang="en-US" dirty="0"/>
+                        <a:t>38</a:t>
+                      </a:r>
+                    </a:p>
+                  </a:txBody>
+                  <a:tcPr/>
+                </a:tc>
+                <a:tc>
+                  <a:txBody>
+                    <a:bodyPr/>
+                    <a:lstStyle/>
+                    <a:p>
+                      <a:r>
+                        <a:rPr lang="en-US" dirty="0"/>
+                        <a:t>4</a:t>
+                      </a:r>
+                    </a:p>
+                  </a:txBody>
+                  <a:tcPr/>
+                </a:tc>
+                <a:extLst>
+                  <a:ext uri="{0D108BD9-81ED-4DB2-BD59-A6C34878D82A}">
+                    <a16:rowId xmlns:a16="http://schemas.microsoft.com/office/drawing/2014/main" val="3791250259"/>
+                  </a:ext>
+                </a:extLst>
+              </a:tr>
+              <a:tr h="440055">
+                <a:tc>
+                  <a:txBody>
+                    <a:bodyPr/>
+                    <a:lstStyle/>
+                    <a:p>
+                      <a:r>
+                        <a:rPr lang="en-US" dirty="0"/>
+                        <a:t>0</a:t>
+                      </a:r>
+                    </a:p>
+                  </a:txBody>
+                  <a:tcPr/>
+                </a:tc>
+                <a:tc>
+                  <a:txBody>
+                    <a:bodyPr/>
+                    <a:lstStyle/>
+                    <a:p>
+                      <a:r>
+                        <a:rPr lang="en-US" dirty="0"/>
+                        <a:t>30</a:t>
+                      </a:r>
+                    </a:p>
+                  </a:txBody>
+                  <a:tcPr/>
+                </a:tc>
+                <a:extLst>
+                  <a:ext uri="{0D108BD9-81ED-4DB2-BD59-A6C34878D82A}">
+                    <a16:rowId xmlns:a16="http://schemas.microsoft.com/office/drawing/2014/main" val="1638858406"/>
+                  </a:ext>
+                </a:extLst>
+              </a:tr>
+            </a:tbl>
+          </a:graphicData>
+        </a:graphic>
+      </p:graphicFrame>
     </p:spTree>
   </p:cSld>
   <p:clrMapOvr>
@@ -7393,7 +8365,7 @@
 </p:sld>
 </file>
 
-<file path=ppt/slides/slide5.xml><?xml version="1.0" encoding="utf-8"?>
+<file path=ppt/slides/slide7.xml><?xml version="1.0" encoding="utf-8"?>
 <p:sld xmlns:a="http://schemas.openxmlformats.org/drawingml/2006/main" xmlns:r="http://schemas.openxmlformats.org/officeDocument/2006/relationships" xmlns:p="http://schemas.openxmlformats.org/presentationml/2006/main">
   <p:cSld>
     <p:spTree>
@@ -7445,67 +8417,830 @@
               <a:buNone/>
             </a:pPr>
             <a:r>
-              <a:rPr lang="en"/>
-              <a:t>Evaluating De-escalation Scenarios: Result</a:t>
+              <a:rPr lang="en" dirty="0"/>
+              <a:t>Result – Score Prediction </a:t>
             </a:r>
-            <a:endParaRPr/>
+            <a:endParaRPr dirty="0"/>
           </a:p>
         </p:txBody>
       </p:sp>
+      <p:graphicFrame>
+        <p:nvGraphicFramePr>
+          <p:cNvPr id="4" name="Table 3">
+            <a:extLst>
+              <a:ext uri="{FF2B5EF4-FFF2-40B4-BE49-F238E27FC236}">
+                <a16:creationId xmlns:a16="http://schemas.microsoft.com/office/drawing/2014/main" id="{BEB33F62-89D7-F806-6E34-471951D083FC}"/>
+              </a:ext>
+            </a:extLst>
+          </p:cNvPr>
+          <p:cNvGraphicFramePr>
+            <a:graphicFrameLocks noGrp="1"/>
+          </p:cNvGraphicFramePr>
+          <p:nvPr>
+            <p:extLst>
+              <p:ext uri="{D42A27DB-BD31-4B8C-83A1-F6EECF244321}">
+                <p14:modId xmlns:p14="http://schemas.microsoft.com/office/powerpoint/2010/main" val="2774429793"/>
+              </p:ext>
+            </p:extLst>
+          </p:nvPr>
+        </p:nvGraphicFramePr>
+        <p:xfrm>
+          <a:off x="311699" y="1431470"/>
+          <a:ext cx="3313243" cy="2770416"/>
+        </p:xfrm>
+        <a:graphic>
+          <a:graphicData uri="http://schemas.openxmlformats.org/drawingml/2006/table">
+            <a:tbl>
+              <a:tblPr>
+                <a:tableStyleId>{86AB57DF-A9DF-48E0-80DA-5916A95E6225}</a:tableStyleId>
+              </a:tblPr>
+              <a:tblGrid>
+                <a:gridCol w="1023648">
+                  <a:extLst>
+                    <a:ext uri="{9D8B030D-6E8A-4147-A177-3AD203B41FA5}">
+                      <a16:colId xmlns:a16="http://schemas.microsoft.com/office/drawing/2014/main" val="462752245"/>
+                    </a:ext>
+                  </a:extLst>
+                </a:gridCol>
+                <a:gridCol w="1285004">
+                  <a:extLst>
+                    <a:ext uri="{9D8B030D-6E8A-4147-A177-3AD203B41FA5}">
+                      <a16:colId xmlns:a16="http://schemas.microsoft.com/office/drawing/2014/main" val="1480372737"/>
+                    </a:ext>
+                  </a:extLst>
+                </a:gridCol>
+                <a:gridCol w="1004591">
+                  <a:extLst>
+                    <a:ext uri="{9D8B030D-6E8A-4147-A177-3AD203B41FA5}">
+                      <a16:colId xmlns:a16="http://schemas.microsoft.com/office/drawing/2014/main" val="3481804171"/>
+                    </a:ext>
+                  </a:extLst>
+                </a:gridCol>
+              </a:tblGrid>
+              <a:tr h="307824">
+                <a:tc>
+                  <a:txBody>
+                    <a:bodyPr/>
+                    <a:lstStyle/>
+                    <a:p>
+                      <a:pPr algn="l" fontAlgn="b">
+                        <a:buNone/>
+                      </a:pPr>
+                      <a:endParaRPr lang="en-US" sz="1100" b="0" i="0" u="none" strike="noStrike">
+                        <a:solidFill>
+                          <a:srgbClr val="000000"/>
+                        </a:solidFill>
+                        <a:effectLst/>
+                        <a:latin typeface="Calibri" panose="020F0502020204030204" pitchFamily="34" charset="0"/>
+                      </a:endParaRPr>
+                    </a:p>
+                  </a:txBody>
+                  <a:tcPr marL="9525" marR="9525" marT="9525" marB="0" anchor="b"/>
+                </a:tc>
+                <a:tc>
+                  <a:txBody>
+                    <a:bodyPr/>
+                    <a:lstStyle/>
+                    <a:p>
+                      <a:pPr algn="ctr" fontAlgn="t">
+                        <a:buNone/>
+                      </a:pPr>
+                      <a:r>
+                        <a:rPr lang="en-US" sz="1100" u="none" strike="noStrike">
+                          <a:effectLst/>
+                        </a:rPr>
+                        <a:t>look_Real=1</a:t>
+                      </a:r>
+                      <a:endParaRPr lang="en-US" sz="1100" b="1" i="0" u="none" strike="noStrike">
+                        <a:solidFill>
+                          <a:srgbClr val="000000"/>
+                        </a:solidFill>
+                        <a:effectLst/>
+                        <a:latin typeface="Calibri" panose="020F0502020204030204" pitchFamily="34" charset="0"/>
+                      </a:endParaRPr>
+                    </a:p>
+                  </a:txBody>
+                  <a:tcPr marL="9525" marR="9525" marT="9525" marB="0"/>
+                </a:tc>
+                <a:tc>
+                  <a:txBody>
+                    <a:bodyPr/>
+                    <a:lstStyle/>
+                    <a:p>
+                      <a:pPr algn="ctr" fontAlgn="t">
+                        <a:buNone/>
+                      </a:pPr>
+                      <a:r>
+                        <a:rPr lang="en-US" sz="1100" u="none" strike="noStrike">
+                          <a:effectLst/>
+                        </a:rPr>
+                        <a:t>look_Real=0</a:t>
+                      </a:r>
+                      <a:endParaRPr lang="en-US" sz="1100" b="1" i="0" u="none" strike="noStrike">
+                        <a:solidFill>
+                          <a:srgbClr val="000000"/>
+                        </a:solidFill>
+                        <a:effectLst/>
+                        <a:latin typeface="Calibri" panose="020F0502020204030204" pitchFamily="34" charset="0"/>
+                      </a:endParaRPr>
+                    </a:p>
+                  </a:txBody>
+                  <a:tcPr marL="9525" marR="9525" marT="9525" marB="0"/>
+                </a:tc>
+                <a:extLst>
+                  <a:ext uri="{0D108BD9-81ED-4DB2-BD59-A6C34878D82A}">
+                    <a16:rowId xmlns:a16="http://schemas.microsoft.com/office/drawing/2014/main" val="2364024701"/>
+                  </a:ext>
+                </a:extLst>
+              </a:tr>
+              <a:tr h="307824">
+                <a:tc>
+                  <a:txBody>
+                    <a:bodyPr/>
+                    <a:lstStyle/>
+                    <a:p>
+                      <a:pPr algn="ctr" fontAlgn="t">
+                        <a:buNone/>
+                      </a:pPr>
+                      <a:r>
+                        <a:rPr lang="en-US" sz="1100" u="none" strike="noStrike">
+                          <a:effectLst/>
+                        </a:rPr>
+                        <a:t>count</a:t>
+                      </a:r>
+                      <a:endParaRPr lang="en-US" sz="1100" b="1" i="0" u="none" strike="noStrike">
+                        <a:solidFill>
+                          <a:srgbClr val="000000"/>
+                        </a:solidFill>
+                        <a:effectLst/>
+                        <a:latin typeface="Calibri" panose="020F0502020204030204" pitchFamily="34" charset="0"/>
+                      </a:endParaRPr>
+                    </a:p>
+                  </a:txBody>
+                  <a:tcPr marL="9525" marR="9525" marT="9525" marB="0"/>
+                </a:tc>
+                <a:tc>
+                  <a:txBody>
+                    <a:bodyPr/>
+                    <a:lstStyle/>
+                    <a:p>
+                      <a:pPr algn="r" fontAlgn="b">
+                        <a:buNone/>
+                      </a:pPr>
+                      <a:r>
+                        <a:rPr lang="en-US" sz="1100" u="none" strike="noStrike">
+                          <a:effectLst/>
+                        </a:rPr>
+                        <a:t>30</a:t>
+                      </a:r>
+                      <a:endParaRPr lang="en-US" sz="1100" b="0" i="0" u="none" strike="noStrike">
+                        <a:solidFill>
+                          <a:srgbClr val="000000"/>
+                        </a:solidFill>
+                        <a:effectLst/>
+                        <a:latin typeface="Calibri" panose="020F0502020204030204" pitchFamily="34" charset="0"/>
+                      </a:endParaRPr>
+                    </a:p>
+                  </a:txBody>
+                  <a:tcPr marL="9525" marR="9525" marT="9525" marB="0" anchor="b"/>
+                </a:tc>
+                <a:tc>
+                  <a:txBody>
+                    <a:bodyPr/>
+                    <a:lstStyle/>
+                    <a:p>
+                      <a:pPr algn="r" fontAlgn="b">
+                        <a:buNone/>
+                      </a:pPr>
+                      <a:r>
+                        <a:rPr lang="en-US" sz="1100" u="none" strike="noStrike">
+                          <a:effectLst/>
+                        </a:rPr>
+                        <a:t>42</a:t>
+                      </a:r>
+                      <a:endParaRPr lang="en-US" sz="1100" b="0" i="0" u="none" strike="noStrike">
+                        <a:solidFill>
+                          <a:srgbClr val="000000"/>
+                        </a:solidFill>
+                        <a:effectLst/>
+                        <a:latin typeface="Calibri" panose="020F0502020204030204" pitchFamily="34" charset="0"/>
+                      </a:endParaRPr>
+                    </a:p>
+                  </a:txBody>
+                  <a:tcPr marL="9525" marR="9525" marT="9525" marB="0" anchor="b"/>
+                </a:tc>
+                <a:extLst>
+                  <a:ext uri="{0D108BD9-81ED-4DB2-BD59-A6C34878D82A}">
+                    <a16:rowId xmlns:a16="http://schemas.microsoft.com/office/drawing/2014/main" val="3549431502"/>
+                  </a:ext>
+                </a:extLst>
+              </a:tr>
+              <a:tr h="307824">
+                <a:tc>
+                  <a:txBody>
+                    <a:bodyPr/>
+                    <a:lstStyle/>
+                    <a:p>
+                      <a:pPr algn="ctr" fontAlgn="t">
+                        <a:buNone/>
+                      </a:pPr>
+                      <a:r>
+                        <a:rPr lang="en-US" sz="1100" u="none" strike="noStrike">
+                          <a:effectLst/>
+                        </a:rPr>
+                        <a:t>mean</a:t>
+                      </a:r>
+                      <a:endParaRPr lang="en-US" sz="1100" b="1" i="0" u="none" strike="noStrike">
+                        <a:solidFill>
+                          <a:srgbClr val="000000"/>
+                        </a:solidFill>
+                        <a:effectLst/>
+                        <a:latin typeface="Calibri" panose="020F0502020204030204" pitchFamily="34" charset="0"/>
+                      </a:endParaRPr>
+                    </a:p>
+                  </a:txBody>
+                  <a:tcPr marL="9525" marR="9525" marT="9525" marB="0"/>
+                </a:tc>
+                <a:tc>
+                  <a:txBody>
+                    <a:bodyPr/>
+                    <a:lstStyle/>
+                    <a:p>
+                      <a:pPr algn="r" fontAlgn="b">
+                        <a:buNone/>
+                      </a:pPr>
+                      <a:r>
+                        <a:rPr lang="en-US" sz="1100" u="none" strike="noStrike">
+                          <a:effectLst/>
+                        </a:rPr>
+                        <a:t>96.166667</a:t>
+                      </a:r>
+                      <a:endParaRPr lang="en-US" sz="1100" b="0" i="0" u="none" strike="noStrike">
+                        <a:solidFill>
+                          <a:srgbClr val="000000"/>
+                        </a:solidFill>
+                        <a:effectLst/>
+                        <a:latin typeface="Calibri" panose="020F0502020204030204" pitchFamily="34" charset="0"/>
+                      </a:endParaRPr>
+                    </a:p>
+                  </a:txBody>
+                  <a:tcPr marL="9525" marR="9525" marT="9525" marB="0" anchor="b"/>
+                </a:tc>
+                <a:tc>
+                  <a:txBody>
+                    <a:bodyPr/>
+                    <a:lstStyle/>
+                    <a:p>
+                      <a:pPr algn="r" fontAlgn="b">
+                        <a:buNone/>
+                      </a:pPr>
+                      <a:r>
+                        <a:rPr lang="en-US" sz="1100" u="none" strike="noStrike" dirty="0">
+                          <a:effectLst/>
+                        </a:rPr>
+                        <a:t>20.619048</a:t>
+                      </a:r>
+                      <a:endParaRPr lang="en-US" sz="1100" b="0" i="0" u="none" strike="noStrike" dirty="0">
+                        <a:solidFill>
+                          <a:srgbClr val="000000"/>
+                        </a:solidFill>
+                        <a:effectLst/>
+                        <a:latin typeface="Calibri" panose="020F0502020204030204" pitchFamily="34" charset="0"/>
+                      </a:endParaRPr>
+                    </a:p>
+                  </a:txBody>
+                  <a:tcPr marL="9525" marR="9525" marT="9525" marB="0" anchor="b"/>
+                </a:tc>
+                <a:extLst>
+                  <a:ext uri="{0D108BD9-81ED-4DB2-BD59-A6C34878D82A}">
+                    <a16:rowId xmlns:a16="http://schemas.microsoft.com/office/drawing/2014/main" val="785374813"/>
+                  </a:ext>
+                </a:extLst>
+              </a:tr>
+              <a:tr h="307824">
+                <a:tc>
+                  <a:txBody>
+                    <a:bodyPr/>
+                    <a:lstStyle/>
+                    <a:p>
+                      <a:pPr algn="ctr" fontAlgn="t">
+                        <a:buNone/>
+                      </a:pPr>
+                      <a:r>
+                        <a:rPr lang="en-US" sz="1100" u="none" strike="noStrike">
+                          <a:effectLst/>
+                        </a:rPr>
+                        <a:t>std</a:t>
+                      </a:r>
+                      <a:endParaRPr lang="en-US" sz="1100" b="1" i="0" u="none" strike="noStrike">
+                        <a:solidFill>
+                          <a:srgbClr val="000000"/>
+                        </a:solidFill>
+                        <a:effectLst/>
+                        <a:latin typeface="Calibri" panose="020F0502020204030204" pitchFamily="34" charset="0"/>
+                      </a:endParaRPr>
+                    </a:p>
+                  </a:txBody>
+                  <a:tcPr marL="9525" marR="9525" marT="9525" marB="0"/>
+                </a:tc>
+                <a:tc>
+                  <a:txBody>
+                    <a:bodyPr/>
+                    <a:lstStyle/>
+                    <a:p>
+                      <a:pPr algn="r" fontAlgn="b">
+                        <a:buNone/>
+                      </a:pPr>
+                      <a:r>
+                        <a:rPr lang="en-US" sz="1100" u="none" strike="noStrike">
+                          <a:effectLst/>
+                        </a:rPr>
+                        <a:t>2.393718</a:t>
+                      </a:r>
+                      <a:endParaRPr lang="en-US" sz="1100" b="0" i="0" u="none" strike="noStrike">
+                        <a:solidFill>
+                          <a:srgbClr val="000000"/>
+                        </a:solidFill>
+                        <a:effectLst/>
+                        <a:latin typeface="Calibri" panose="020F0502020204030204" pitchFamily="34" charset="0"/>
+                      </a:endParaRPr>
+                    </a:p>
+                  </a:txBody>
+                  <a:tcPr marL="9525" marR="9525" marT="9525" marB="0" anchor="b"/>
+                </a:tc>
+                <a:tc>
+                  <a:txBody>
+                    <a:bodyPr/>
+                    <a:lstStyle/>
+                    <a:p>
+                      <a:pPr algn="r" fontAlgn="b">
+                        <a:buNone/>
+                      </a:pPr>
+                      <a:r>
+                        <a:rPr lang="en-US" sz="1100" u="none" strike="noStrike">
+                          <a:effectLst/>
+                        </a:rPr>
+                        <a:t>24.861521</a:t>
+                      </a:r>
+                      <a:endParaRPr lang="en-US" sz="1100" b="0" i="0" u="none" strike="noStrike">
+                        <a:solidFill>
+                          <a:srgbClr val="000000"/>
+                        </a:solidFill>
+                        <a:effectLst/>
+                        <a:latin typeface="Calibri" panose="020F0502020204030204" pitchFamily="34" charset="0"/>
+                      </a:endParaRPr>
+                    </a:p>
+                  </a:txBody>
+                  <a:tcPr marL="9525" marR="9525" marT="9525" marB="0" anchor="b"/>
+                </a:tc>
+                <a:extLst>
+                  <a:ext uri="{0D108BD9-81ED-4DB2-BD59-A6C34878D82A}">
+                    <a16:rowId xmlns:a16="http://schemas.microsoft.com/office/drawing/2014/main" val="1402925460"/>
+                  </a:ext>
+                </a:extLst>
+              </a:tr>
+              <a:tr h="307824">
+                <a:tc>
+                  <a:txBody>
+                    <a:bodyPr/>
+                    <a:lstStyle/>
+                    <a:p>
+                      <a:pPr algn="ctr" fontAlgn="t">
+                        <a:buNone/>
+                      </a:pPr>
+                      <a:r>
+                        <a:rPr lang="en-US" sz="1100" u="none" strike="noStrike" dirty="0">
+                          <a:effectLst/>
+                        </a:rPr>
+                        <a:t>min</a:t>
+                      </a:r>
+                      <a:endParaRPr lang="en-US" sz="1100" b="1" i="0" u="none" strike="noStrike" dirty="0">
+                        <a:solidFill>
+                          <a:srgbClr val="000000"/>
+                        </a:solidFill>
+                        <a:effectLst/>
+                        <a:latin typeface="Calibri" panose="020F0502020204030204" pitchFamily="34" charset="0"/>
+                      </a:endParaRPr>
+                    </a:p>
+                  </a:txBody>
+                  <a:tcPr marL="9525" marR="9525" marT="9525" marB="0"/>
+                </a:tc>
+                <a:tc>
+                  <a:txBody>
+                    <a:bodyPr/>
+                    <a:lstStyle/>
+                    <a:p>
+                      <a:pPr algn="r" fontAlgn="b">
+                        <a:buNone/>
+                      </a:pPr>
+                      <a:r>
+                        <a:rPr lang="en-US" sz="1100" u="none" strike="noStrike">
+                          <a:effectLst/>
+                        </a:rPr>
+                        <a:t>87</a:t>
+                      </a:r>
+                      <a:endParaRPr lang="en-US" sz="1100" b="0" i="0" u="none" strike="noStrike">
+                        <a:solidFill>
+                          <a:srgbClr val="000000"/>
+                        </a:solidFill>
+                        <a:effectLst/>
+                        <a:latin typeface="Calibri" panose="020F0502020204030204" pitchFamily="34" charset="0"/>
+                      </a:endParaRPr>
+                    </a:p>
+                  </a:txBody>
+                  <a:tcPr marL="9525" marR="9525" marT="9525" marB="0" anchor="b"/>
+                </a:tc>
+                <a:tc>
+                  <a:txBody>
+                    <a:bodyPr/>
+                    <a:lstStyle/>
+                    <a:p>
+                      <a:pPr algn="r" fontAlgn="b">
+                        <a:buNone/>
+                      </a:pPr>
+                      <a:r>
+                        <a:rPr lang="en-US" sz="1100" u="none" strike="noStrike">
+                          <a:effectLst/>
+                        </a:rPr>
+                        <a:t>5</a:t>
+                      </a:r>
+                      <a:endParaRPr lang="en-US" sz="1100" b="0" i="0" u="none" strike="noStrike">
+                        <a:solidFill>
+                          <a:srgbClr val="000000"/>
+                        </a:solidFill>
+                        <a:effectLst/>
+                        <a:latin typeface="Calibri" panose="020F0502020204030204" pitchFamily="34" charset="0"/>
+                      </a:endParaRPr>
+                    </a:p>
+                  </a:txBody>
+                  <a:tcPr marL="9525" marR="9525" marT="9525" marB="0" anchor="b"/>
+                </a:tc>
+                <a:extLst>
+                  <a:ext uri="{0D108BD9-81ED-4DB2-BD59-A6C34878D82A}">
+                    <a16:rowId xmlns:a16="http://schemas.microsoft.com/office/drawing/2014/main" val="1032278894"/>
+                  </a:ext>
+                </a:extLst>
+              </a:tr>
+              <a:tr h="307824">
+                <a:tc>
+                  <a:txBody>
+                    <a:bodyPr/>
+                    <a:lstStyle/>
+                    <a:p>
+                      <a:pPr algn="ctr" fontAlgn="t">
+                        <a:buNone/>
+                      </a:pPr>
+                      <a:r>
+                        <a:rPr lang="en-US" sz="1100" u="none" strike="noStrike">
+                          <a:effectLst/>
+                        </a:rPr>
+                        <a:t>25%</a:t>
+                      </a:r>
+                      <a:endParaRPr lang="en-US" sz="1100" b="1" i="0" u="none" strike="noStrike">
+                        <a:solidFill>
+                          <a:srgbClr val="000000"/>
+                        </a:solidFill>
+                        <a:effectLst/>
+                        <a:latin typeface="Calibri" panose="020F0502020204030204" pitchFamily="34" charset="0"/>
+                      </a:endParaRPr>
+                    </a:p>
+                  </a:txBody>
+                  <a:tcPr marL="9525" marR="9525" marT="9525" marB="0"/>
+                </a:tc>
+                <a:tc>
+                  <a:txBody>
+                    <a:bodyPr/>
+                    <a:lstStyle/>
+                    <a:p>
+                      <a:pPr algn="r" fontAlgn="b">
+                        <a:buNone/>
+                      </a:pPr>
+                      <a:r>
+                        <a:rPr lang="en-US" sz="1100" u="none" strike="noStrike">
+                          <a:effectLst/>
+                        </a:rPr>
+                        <a:t>95</a:t>
+                      </a:r>
+                      <a:endParaRPr lang="en-US" sz="1100" b="0" i="0" u="none" strike="noStrike">
+                        <a:solidFill>
+                          <a:srgbClr val="000000"/>
+                        </a:solidFill>
+                        <a:effectLst/>
+                        <a:latin typeface="Calibri" panose="020F0502020204030204" pitchFamily="34" charset="0"/>
+                      </a:endParaRPr>
+                    </a:p>
+                  </a:txBody>
+                  <a:tcPr marL="9525" marR="9525" marT="9525" marB="0" anchor="b"/>
+                </a:tc>
+                <a:tc>
+                  <a:txBody>
+                    <a:bodyPr/>
+                    <a:lstStyle/>
+                    <a:p>
+                      <a:pPr algn="r" fontAlgn="b">
+                        <a:buNone/>
+                      </a:pPr>
+                      <a:r>
+                        <a:rPr lang="en-US" sz="1100" u="none" strike="noStrike">
+                          <a:effectLst/>
+                        </a:rPr>
+                        <a:t>10</a:t>
+                      </a:r>
+                      <a:endParaRPr lang="en-US" sz="1100" b="0" i="0" u="none" strike="noStrike">
+                        <a:solidFill>
+                          <a:srgbClr val="000000"/>
+                        </a:solidFill>
+                        <a:effectLst/>
+                        <a:latin typeface="Calibri" panose="020F0502020204030204" pitchFamily="34" charset="0"/>
+                      </a:endParaRPr>
+                    </a:p>
+                  </a:txBody>
+                  <a:tcPr marL="9525" marR="9525" marT="9525" marB="0" anchor="b"/>
+                </a:tc>
+                <a:extLst>
+                  <a:ext uri="{0D108BD9-81ED-4DB2-BD59-A6C34878D82A}">
+                    <a16:rowId xmlns:a16="http://schemas.microsoft.com/office/drawing/2014/main" val="341906390"/>
+                  </a:ext>
+                </a:extLst>
+              </a:tr>
+              <a:tr h="307824">
+                <a:tc>
+                  <a:txBody>
+                    <a:bodyPr/>
+                    <a:lstStyle/>
+                    <a:p>
+                      <a:pPr algn="ctr" fontAlgn="t">
+                        <a:buNone/>
+                      </a:pPr>
+                      <a:r>
+                        <a:rPr lang="en-US" sz="1100" u="none" strike="noStrike">
+                          <a:effectLst/>
+                        </a:rPr>
+                        <a:t>50%</a:t>
+                      </a:r>
+                      <a:endParaRPr lang="en-US" sz="1100" b="1" i="0" u="none" strike="noStrike">
+                        <a:solidFill>
+                          <a:srgbClr val="000000"/>
+                        </a:solidFill>
+                        <a:effectLst/>
+                        <a:latin typeface="Calibri" panose="020F0502020204030204" pitchFamily="34" charset="0"/>
+                      </a:endParaRPr>
+                    </a:p>
+                  </a:txBody>
+                  <a:tcPr marL="9525" marR="9525" marT="9525" marB="0"/>
+                </a:tc>
+                <a:tc>
+                  <a:txBody>
+                    <a:bodyPr/>
+                    <a:lstStyle/>
+                    <a:p>
+                      <a:pPr algn="r" fontAlgn="b">
+                        <a:buNone/>
+                      </a:pPr>
+                      <a:r>
+                        <a:rPr lang="en-US" sz="1100" u="none" strike="noStrike" dirty="0">
+                          <a:effectLst/>
+                        </a:rPr>
+                        <a:t>97</a:t>
+                      </a:r>
+                      <a:endParaRPr lang="en-US" sz="1100" b="0" i="0" u="none" strike="noStrike" dirty="0">
+                        <a:solidFill>
+                          <a:srgbClr val="000000"/>
+                        </a:solidFill>
+                        <a:effectLst/>
+                        <a:latin typeface="Calibri" panose="020F0502020204030204" pitchFamily="34" charset="0"/>
+                      </a:endParaRPr>
+                    </a:p>
+                  </a:txBody>
+                  <a:tcPr marL="9525" marR="9525" marT="9525" marB="0" anchor="b"/>
+                </a:tc>
+                <a:tc>
+                  <a:txBody>
+                    <a:bodyPr/>
+                    <a:lstStyle/>
+                    <a:p>
+                      <a:pPr algn="r" fontAlgn="b">
+                        <a:buNone/>
+                      </a:pPr>
+                      <a:r>
+                        <a:rPr lang="en-US" sz="1100" u="none" strike="noStrike">
+                          <a:effectLst/>
+                        </a:rPr>
+                        <a:t>15</a:t>
+                      </a:r>
+                      <a:endParaRPr lang="en-US" sz="1100" b="0" i="0" u="none" strike="noStrike">
+                        <a:solidFill>
+                          <a:srgbClr val="000000"/>
+                        </a:solidFill>
+                        <a:effectLst/>
+                        <a:latin typeface="Calibri" panose="020F0502020204030204" pitchFamily="34" charset="0"/>
+                      </a:endParaRPr>
+                    </a:p>
+                  </a:txBody>
+                  <a:tcPr marL="9525" marR="9525" marT="9525" marB="0" anchor="b"/>
+                </a:tc>
+                <a:extLst>
+                  <a:ext uri="{0D108BD9-81ED-4DB2-BD59-A6C34878D82A}">
+                    <a16:rowId xmlns:a16="http://schemas.microsoft.com/office/drawing/2014/main" val="3446569858"/>
+                  </a:ext>
+                </a:extLst>
+              </a:tr>
+              <a:tr h="307824">
+                <a:tc>
+                  <a:txBody>
+                    <a:bodyPr/>
+                    <a:lstStyle/>
+                    <a:p>
+                      <a:pPr algn="ctr" fontAlgn="t">
+                        <a:buNone/>
+                      </a:pPr>
+                      <a:r>
+                        <a:rPr lang="en-US" sz="1100" u="none" strike="noStrike">
+                          <a:effectLst/>
+                        </a:rPr>
+                        <a:t>75%</a:t>
+                      </a:r>
+                      <a:endParaRPr lang="en-US" sz="1100" b="1" i="0" u="none" strike="noStrike">
+                        <a:solidFill>
+                          <a:srgbClr val="000000"/>
+                        </a:solidFill>
+                        <a:effectLst/>
+                        <a:latin typeface="Calibri" panose="020F0502020204030204" pitchFamily="34" charset="0"/>
+                      </a:endParaRPr>
+                    </a:p>
+                  </a:txBody>
+                  <a:tcPr marL="9525" marR="9525" marT="9525" marB="0"/>
+                </a:tc>
+                <a:tc>
+                  <a:txBody>
+                    <a:bodyPr/>
+                    <a:lstStyle/>
+                    <a:p>
+                      <a:pPr algn="r" fontAlgn="b">
+                        <a:buNone/>
+                      </a:pPr>
+                      <a:r>
+                        <a:rPr lang="en-US" sz="1100" u="none" strike="noStrike">
+                          <a:effectLst/>
+                        </a:rPr>
+                        <a:t>98</a:t>
+                      </a:r>
+                      <a:endParaRPr lang="en-US" sz="1100" b="0" i="0" u="none" strike="noStrike">
+                        <a:solidFill>
+                          <a:srgbClr val="000000"/>
+                        </a:solidFill>
+                        <a:effectLst/>
+                        <a:latin typeface="Calibri" panose="020F0502020204030204" pitchFamily="34" charset="0"/>
+                      </a:endParaRPr>
+                    </a:p>
+                  </a:txBody>
+                  <a:tcPr marL="9525" marR="9525" marT="9525" marB="0" anchor="b"/>
+                </a:tc>
+                <a:tc>
+                  <a:txBody>
+                    <a:bodyPr/>
+                    <a:lstStyle/>
+                    <a:p>
+                      <a:pPr algn="r" fontAlgn="b">
+                        <a:buNone/>
+                      </a:pPr>
+                      <a:r>
+                        <a:rPr lang="en-US" sz="1100" u="none" strike="noStrike">
+                          <a:effectLst/>
+                        </a:rPr>
+                        <a:t>15</a:t>
+                      </a:r>
+                      <a:endParaRPr lang="en-US" sz="1100" b="0" i="0" u="none" strike="noStrike">
+                        <a:solidFill>
+                          <a:srgbClr val="000000"/>
+                        </a:solidFill>
+                        <a:effectLst/>
+                        <a:latin typeface="Calibri" panose="020F0502020204030204" pitchFamily="34" charset="0"/>
+                      </a:endParaRPr>
+                    </a:p>
+                  </a:txBody>
+                  <a:tcPr marL="9525" marR="9525" marT="9525" marB="0" anchor="b"/>
+                </a:tc>
+                <a:extLst>
+                  <a:ext uri="{0D108BD9-81ED-4DB2-BD59-A6C34878D82A}">
+                    <a16:rowId xmlns:a16="http://schemas.microsoft.com/office/drawing/2014/main" val="1342138121"/>
+                  </a:ext>
+                </a:extLst>
+              </a:tr>
+              <a:tr h="307824">
+                <a:tc>
+                  <a:txBody>
+                    <a:bodyPr/>
+                    <a:lstStyle/>
+                    <a:p>
+                      <a:pPr algn="ctr" fontAlgn="t">
+                        <a:buNone/>
+                      </a:pPr>
+                      <a:r>
+                        <a:rPr lang="en-US" sz="1100" u="none" strike="noStrike">
+                          <a:effectLst/>
+                        </a:rPr>
+                        <a:t>max</a:t>
+                      </a:r>
+                      <a:endParaRPr lang="en-US" sz="1100" b="1" i="0" u="none" strike="noStrike">
+                        <a:solidFill>
+                          <a:srgbClr val="000000"/>
+                        </a:solidFill>
+                        <a:effectLst/>
+                        <a:latin typeface="Calibri" panose="020F0502020204030204" pitchFamily="34" charset="0"/>
+                      </a:endParaRPr>
+                    </a:p>
+                  </a:txBody>
+                  <a:tcPr marL="9525" marR="9525" marT="9525" marB="0"/>
+                </a:tc>
+                <a:tc>
+                  <a:txBody>
+                    <a:bodyPr/>
+                    <a:lstStyle/>
+                    <a:p>
+                      <a:pPr algn="r" fontAlgn="b">
+                        <a:buNone/>
+                      </a:pPr>
+                      <a:r>
+                        <a:rPr lang="en-US" sz="1100" u="none" strike="noStrike">
+                          <a:effectLst/>
+                        </a:rPr>
+                        <a:t>98</a:t>
+                      </a:r>
+                      <a:endParaRPr lang="en-US" sz="1100" b="0" i="0" u="none" strike="noStrike">
+                        <a:solidFill>
+                          <a:srgbClr val="000000"/>
+                        </a:solidFill>
+                        <a:effectLst/>
+                        <a:latin typeface="Calibri" panose="020F0502020204030204" pitchFamily="34" charset="0"/>
+                      </a:endParaRPr>
+                    </a:p>
+                  </a:txBody>
+                  <a:tcPr marL="9525" marR="9525" marT="9525" marB="0" anchor="b"/>
+                </a:tc>
+                <a:tc>
+                  <a:txBody>
+                    <a:bodyPr/>
+                    <a:lstStyle/>
+                    <a:p>
+                      <a:pPr algn="r" fontAlgn="b">
+                        <a:buNone/>
+                      </a:pPr>
+                      <a:r>
+                        <a:rPr lang="en-US" sz="1100" u="none" strike="noStrike" dirty="0">
+                          <a:effectLst/>
+                        </a:rPr>
+                        <a:t>98</a:t>
+                      </a:r>
+                      <a:endParaRPr lang="en-US" sz="1100" b="0" i="0" u="none" strike="noStrike" dirty="0">
+                        <a:solidFill>
+                          <a:srgbClr val="000000"/>
+                        </a:solidFill>
+                        <a:effectLst/>
+                        <a:latin typeface="Calibri" panose="020F0502020204030204" pitchFamily="34" charset="0"/>
+                      </a:endParaRPr>
+                    </a:p>
+                  </a:txBody>
+                  <a:tcPr marL="9525" marR="9525" marT="9525" marB="0" anchor="b"/>
+                </a:tc>
+                <a:extLst>
+                  <a:ext uri="{0D108BD9-81ED-4DB2-BD59-A6C34878D82A}">
+                    <a16:rowId xmlns:a16="http://schemas.microsoft.com/office/drawing/2014/main" val="195949751"/>
+                  </a:ext>
+                </a:extLst>
+              </a:tr>
+            </a:tbl>
+          </a:graphicData>
+        </a:graphic>
+      </p:graphicFrame>
       <p:pic>
         <p:nvPicPr>
-          <p:cNvPr id="81" name="Google Shape;81;p17"/>
-          <p:cNvPicPr preferRelativeResize="0"/>
+          <p:cNvPr id="5" name="Picture 4">
+            <a:extLst>
+              <a:ext uri="{FF2B5EF4-FFF2-40B4-BE49-F238E27FC236}">
+                <a16:creationId xmlns:a16="http://schemas.microsoft.com/office/drawing/2014/main" id="{D0590262-636D-FE2C-37CD-5DF3F38E0B83}"/>
+              </a:ext>
+            </a:extLst>
+          </p:cNvPr>
+          <p:cNvPicPr>
+            <a:picLocks noChangeAspect="1"/>
+          </p:cNvPicPr>
           <p:nvPr/>
         </p:nvPicPr>
         <p:blipFill>
-          <a:blip r:embed="rId3">
-            <a:alphaModFix/>
-          </a:blip>
+          <a:blip r:embed="rId3"/>
           <a:stretch>
             <a:fillRect/>
           </a:stretch>
         </p:blipFill>
         <p:spPr>
           <a:xfrm>
-            <a:off x="185332" y="1101951"/>
-            <a:ext cx="4039545" cy="2723147"/>
+            <a:off x="4187729" y="1163865"/>
+            <a:ext cx="4644571" cy="3371614"/>
           </a:xfrm>
           <a:prstGeom prst="rect">
             <a:avLst/>
           </a:prstGeom>
-          <a:noFill/>
-          <a:ln>
-            <a:noFill/>
-          </a:ln>
-        </p:spPr>
-      </p:pic>
-      <p:pic>
-        <p:nvPicPr>
-          <p:cNvPr id="82" name="Google Shape;82;p17"/>
-          <p:cNvPicPr preferRelativeResize="0"/>
-          <p:nvPr/>
-        </p:nvPicPr>
-        <p:blipFill>
-          <a:blip r:embed="rId4">
-            <a:alphaModFix/>
-          </a:blip>
-          <a:stretch>
-            <a:fillRect/>
-          </a:stretch>
-        </p:blipFill>
-        <p:spPr>
-          <a:xfrm>
-            <a:off x="4292724" y="1017725"/>
-            <a:ext cx="4039545" cy="2891600"/>
-          </a:xfrm>
-          <a:prstGeom prst="rect">
-            <a:avLst/>
-          </a:prstGeom>
-          <a:noFill/>
-          <a:ln>
-            <a:noFill/>
-          </a:ln>
         </p:spPr>
       </p:pic>
     </p:spTree>
@@ -7516,7 +9251,7 @@
 </p:sld>
 </file>
 
-<file path=ppt/slides/slide6.xml><?xml version="1.0" encoding="utf-8"?>
+<file path=ppt/slides/slide8.xml><?xml version="1.0" encoding="utf-8"?>
 <p:sld xmlns:a="http://schemas.openxmlformats.org/drawingml/2006/main" xmlns:r="http://schemas.openxmlformats.org/officeDocument/2006/relationships" xmlns:p="http://schemas.openxmlformats.org/presentationml/2006/main">
   <p:cSld>
     <p:spTree>
@@ -7568,10 +9303,10 @@
               <a:buNone/>
             </a:pPr>
             <a:r>
-              <a:rPr lang="en"/>
-              <a:t>Evaluating De-escalation Scenarios: Where to use</a:t>
+              <a:rPr lang="en" dirty="0"/>
+              <a:t>Summary</a:t>
             </a:r>
-            <a:endParaRPr/>
+            <a:endParaRPr dirty="0"/>
           </a:p>
         </p:txBody>
       </p:sp>
@@ -7614,261 +9349,16 @@
               <a:buChar char="➢"/>
             </a:pPr>
             <a:r>
-              <a:rPr lang="en">
+              <a:rPr lang="en-US" dirty="0">
                 <a:solidFill>
                   <a:schemeClr val="dk1"/>
                 </a:solidFill>
               </a:rPr>
-              <a:t>Automatically triggers a final evaluation to end the training session. </a:t>
+              <a:t>Results look good. Four out of 73 are incorrect. The rest are okay with a consistent score.</a:t>
             </a:r>
-            <a:endParaRPr>
+            <a:endParaRPr dirty="0">
               <a:solidFill>
                 <a:schemeClr val="dk1"/>
-              </a:solidFill>
-            </a:endParaRPr>
-          </a:p>
-          <a:p>
-            <a:pPr marL="457200" lvl="0" indent="-342900" algn="l" rtl="0">
-              <a:spcBef>
-                <a:spcPts val="0"/>
-              </a:spcBef>
-              <a:spcAft>
-                <a:spcPts val="0"/>
-              </a:spcAft>
-              <a:buClr>
-                <a:schemeClr val="dk1"/>
-              </a:buClr>
-              <a:buSzPts val="1800"/>
-              <a:buChar char="➢"/>
-            </a:pPr>
-            <a:r>
-              <a:rPr lang="en">
-                <a:solidFill>
-                  <a:schemeClr val="dk1"/>
-                </a:solidFill>
-              </a:rPr>
-              <a:t>Dynamically concludes training and transitions to an evaluation state.</a:t>
-            </a:r>
-            <a:endParaRPr>
-              <a:solidFill>
-                <a:schemeClr val="dk1"/>
-              </a:solidFill>
-            </a:endParaRPr>
-          </a:p>
-          <a:p>
-            <a:pPr marL="457200" lvl="0" indent="-342900" algn="l" rtl="0">
-              <a:spcBef>
-                <a:spcPts val="0"/>
-              </a:spcBef>
-              <a:spcAft>
-                <a:spcPts val="0"/>
-              </a:spcAft>
-              <a:buClr>
-                <a:schemeClr val="dk1"/>
-              </a:buClr>
-              <a:buSzPts val="1800"/>
-              <a:buChar char="➢"/>
-            </a:pPr>
-            <a:r>
-              <a:rPr lang="en">
-                <a:solidFill>
-                  <a:schemeClr val="dk1"/>
-                </a:solidFill>
-              </a:rPr>
-              <a:t>Replaces static phrases with an automated technique to end training.</a:t>
-            </a:r>
-            <a:endParaRPr>
-              <a:solidFill>
-                <a:schemeClr val="dk1"/>
-              </a:solidFill>
-            </a:endParaRPr>
-          </a:p>
-          <a:p>
-            <a:pPr marL="0" lvl="0" indent="0" algn="l" rtl="0">
-              <a:spcBef>
-                <a:spcPts val="1200"/>
-              </a:spcBef>
-              <a:spcAft>
-                <a:spcPts val="1200"/>
-              </a:spcAft>
-              <a:buNone/>
-            </a:pPr>
-            <a:endParaRPr/>
-          </a:p>
-        </p:txBody>
-      </p:sp>
-    </p:spTree>
-  </p:cSld>
-  <p:clrMapOvr>
-    <a:masterClrMapping/>
-  </p:clrMapOvr>
-</p:sld>
-</file>
-
-<file path=ppt/slides/slide7.xml><?xml version="1.0" encoding="utf-8"?>
-<p:sld xmlns:a="http://schemas.openxmlformats.org/drawingml/2006/main" xmlns:r="http://schemas.openxmlformats.org/officeDocument/2006/relationships" xmlns:p="http://schemas.openxmlformats.org/presentationml/2006/main">
-  <p:cSld>
-    <p:spTree>
-      <p:nvGrpSpPr>
-        <p:cNvPr id="1" name="Shape 92"/>
-        <p:cNvGrpSpPr/>
-        <p:nvPr/>
-      </p:nvGrpSpPr>
-      <p:grpSpPr>
-        <a:xfrm>
-          <a:off x="0" y="0"/>
-          <a:ext cx="0" cy="0"/>
-          <a:chOff x="0" y="0"/>
-          <a:chExt cx="0" cy="0"/>
-        </a:xfrm>
-      </p:grpSpPr>
-      <p:sp>
-        <p:nvSpPr>
-          <p:cNvPr id="93" name="Google Shape;93;p19"/>
-          <p:cNvSpPr txBox="1">
-            <a:spLocks noGrp="1"/>
-          </p:cNvSpPr>
-          <p:nvPr>
-            <p:ph type="title"/>
-          </p:nvPr>
-        </p:nvSpPr>
-        <p:spPr>
-          <a:xfrm>
-            <a:off x="311700" y="445025"/>
-            <a:ext cx="8520600" cy="572700"/>
-          </a:xfrm>
-          <a:prstGeom prst="rect">
-            <a:avLst/>
-          </a:prstGeom>
-        </p:spPr>
-        <p:txBody>
-          <a:bodyPr spcFirstLastPara="1" wrap="square" lIns="91425" tIns="91425" rIns="91425" bIns="91425" anchor="t" anchorCtr="0">
-            <a:normAutofit fontScale="90000"/>
-          </a:bodyPr>
-          <a:lstStyle/>
-          <a:p>
-            <a:pPr marL="0" lvl="0" indent="0" algn="l" rtl="0">
-              <a:spcBef>
-                <a:spcPts val="0"/>
-              </a:spcBef>
-              <a:spcAft>
-                <a:spcPts val="0"/>
-              </a:spcAft>
-              <a:buNone/>
-            </a:pPr>
-            <a:r>
-              <a:rPr lang="en"/>
-              <a:t>Evaluation of Role-Playing</a:t>
-            </a:r>
-            <a:endParaRPr/>
-          </a:p>
-        </p:txBody>
-      </p:sp>
-      <p:sp>
-        <p:nvSpPr>
-          <p:cNvPr id="94" name="Google Shape;94;p19"/>
-          <p:cNvSpPr txBox="1">
-            <a:spLocks noGrp="1"/>
-          </p:cNvSpPr>
-          <p:nvPr>
-            <p:ph type="body" idx="1"/>
-          </p:nvPr>
-        </p:nvSpPr>
-        <p:spPr>
-          <a:xfrm>
-            <a:off x="311700" y="1152475"/>
-            <a:ext cx="8520600" cy="3416400"/>
-          </a:xfrm>
-          <a:prstGeom prst="rect">
-            <a:avLst/>
-          </a:prstGeom>
-        </p:spPr>
-        <p:txBody>
-          <a:bodyPr spcFirstLastPara="1" wrap="square" lIns="91425" tIns="91425" rIns="91425" bIns="91425" anchor="t" anchorCtr="0">
-            <a:normAutofit/>
-          </a:bodyPr>
-          <a:lstStyle/>
-          <a:p>
-            <a:pPr marL="457200" lvl="0" indent="-342900" algn="l" rtl="0">
-              <a:spcBef>
-                <a:spcPts val="0"/>
-              </a:spcBef>
-              <a:spcAft>
-                <a:spcPts val="0"/>
-              </a:spcAft>
-              <a:buClr>
-                <a:srgbClr val="000000"/>
-              </a:buClr>
-              <a:buSzPts val="1800"/>
-              <a:buChar char="➢"/>
-            </a:pPr>
-            <a:r>
-              <a:rPr lang="en">
-                <a:solidFill>
-                  <a:srgbClr val="000000"/>
-                </a:solidFill>
-              </a:rPr>
-              <a:t>The current dataset needs to be updated by adding negative examples. </a:t>
-            </a:r>
-            <a:endParaRPr>
-              <a:solidFill>
-                <a:srgbClr val="000000"/>
-              </a:solidFill>
-            </a:endParaRPr>
-          </a:p>
-          <a:p>
-            <a:pPr marL="457200" lvl="0" indent="-342900" algn="l" rtl="0">
-              <a:spcBef>
-                <a:spcPts val="0"/>
-              </a:spcBef>
-              <a:spcAft>
-                <a:spcPts val="0"/>
-              </a:spcAft>
-              <a:buClr>
-                <a:srgbClr val="000000"/>
-              </a:buClr>
-              <a:buSzPts val="1800"/>
-              <a:buChar char="➢"/>
-            </a:pPr>
-            <a:r>
-              <a:rPr lang="en">
-                <a:solidFill>
-                  <a:srgbClr val="000000"/>
-                </a:solidFill>
-              </a:rPr>
-              <a:t>Our plan is to add at least 30 negative examples.</a:t>
-            </a:r>
-            <a:endParaRPr>
-              <a:solidFill>
-                <a:srgbClr val="000000"/>
-              </a:solidFill>
-            </a:endParaRPr>
-          </a:p>
-          <a:p>
-            <a:pPr marL="457200" lvl="0" indent="-342900" algn="l" rtl="0">
-              <a:spcBef>
-                <a:spcPts val="0"/>
-              </a:spcBef>
-              <a:spcAft>
-                <a:spcPts val="0"/>
-              </a:spcAft>
-              <a:buClr>
-                <a:srgbClr val="000000"/>
-              </a:buClr>
-              <a:buSzPts val="1800"/>
-              <a:buChar char="➢"/>
-            </a:pPr>
-            <a:r>
-              <a:rPr lang="en">
-                <a:solidFill>
-                  <a:srgbClr val="000000"/>
-                </a:solidFill>
-              </a:rPr>
-              <a:t>Currently, the average role-playing accuracy is around 95% when evaluating only positive examples.</a:t>
-            </a:r>
-            <a:endParaRPr>
-              <a:solidFill>
-                <a:srgbClr val="000000"/>
               </a:solidFill>
             </a:endParaRPr>
           </a:p>

</xml_diff>